<commit_message>
Team guide: Adithya as project lead, named owners, status + talk order; add slides, demo script PDF, paper writing plan
Co-Authored-By: Claude Opus 5.5 <noreply@anthropic.com>
</commit_message>
<xml_diff>
--- a/docs/CodeMigrate_Review.pptx
+++ b/docs/CodeMigrate_Review.pptx
@@ -4,6 +4,9 @@
   <p:sldMasterIdLst>
     <p:sldMasterId id="2147483648" r:id="rId1"/>
   </p:sldMasterIdLst>
+  <p:notesMasterIdLst>
+    <p:notesMasterId r:id="rId17"/>
+  </p:notesMasterIdLst>
   <p:sldIdLst>
     <p:sldId id="256" r:id="rId2"/>
     <p:sldId id="257" r:id="rId3"/>
@@ -21,9 +24,6 @@
     <p:sldId id="269" r:id="rId15"/>
     <p:sldId id="270" r:id="rId16"/>
   </p:sldIdLst>
-  <p:notesMasterIdLst>
-    <p:notesMasterId r:id="rId17"/>
-  </p:notesMasterIdLst>
   <p:sldSz cx="12192000" cy="6858000"/>
   <p:notesSz cx="6858000" cy="12192000"/>
   <p:defaultTextStyle>
@@ -121,20 +121,20 @@
   <p:extLst>
     <p:ext uri="{521415D9-36F7-43E2-AB2F-B90AF26B5E84}">
       <p14:sectionLst xmlns:p14="http://schemas.microsoft.com/office/powerpoint/2010/main">
-        <p14:section name="Problem" id="{02cd4eb0-b29e-75f8-e8ac-9fd9dc8146a8}">
+        <p14:section name="Problem" id="{02CD4EB0-B29E-75F8-E8AC-9FD9DC8146A8}">
           <p14:sldIdLst>
             <p14:sldId id="256"/>
             <p14:sldId id="257"/>
             <p14:sldId id="258"/>
           </p14:sldIdLst>
         </p14:section>
-        <p14:section name="Method" id="{a2b169cd-cbfb-daf5-68d9-ccb3af32c476}">
+        <p14:section name="Method" id="{A2B169CD-CBFB-DAF5-68D9-CCB3AF32C476}">
           <p14:sldIdLst>
             <p14:sldId id="259"/>
             <p14:sldId id="260"/>
           </p14:sldIdLst>
         </p14:section>
-        <p14:section name="Results" id="{7560b7a7-c6ea-ab1e-008f-04eb0ea5b043}">
+        <p14:section name="Results" id="{7560B7A7-C6EA-AB1E-008F-04EB0EA5B043}">
           <p14:sldIdLst>
             <p14:sldId id="261"/>
             <p14:sldId id="262"/>
@@ -143,7 +143,7 @@
             <p14:sldId id="265"/>
           </p14:sldIdLst>
         </p14:section>
-        <p14:section name="Wrap-up" id="{de451929-2be2-ca5d-7eb0-69bbd3107bd0}">
+        <p14:section name="Wrap-up" id="{DE451929-2BE2-CA5D-7EB0-69BBD3107BD0}">
           <p14:sldIdLst>
             <p14:sldId id="266"/>
             <p14:sldId id="267"/>
@@ -164,7 +164,9 @@
 <file path=ppt/charts/chart1.xml><?xml version="1.0" encoding="utf-8"?>
 <c:chartSpace xmlns:c="http://schemas.openxmlformats.org/drawingml/2006/chart" xmlns:a="http://schemas.openxmlformats.org/drawingml/2006/main" xmlns:r="http://schemas.openxmlformats.org/officeDocument/2006/relationships">
   <c:date1904 val="0"/>
+  <c:lang val="en-US"/>
   <c:roundedCorners val="1"/>
+  <c:style val="2"/>
   <c:chart>
     <c:title>
       <c:tx>
@@ -181,7 +183,7 @@
               </a:defRPr>
             </a:pPr>
             <a:r>
-              <a:rPr sz="1400" b="0" i="0" u="none" strike="noStrike">
+              <a:rPr lang="en-IN" sz="1400" b="0" i="0" u="none" strike="noStrike">
                 <a:solidFill>
                   <a:srgbClr val="14213D"/>
                 </a:solidFill>
@@ -225,18 +227,26 @@
           <c:invertIfNegative val="0"/>
           <c:dLbls>
             <c:numFmt formatCode="0.0" sourceLinked="0"/>
+            <c:spPr>
+              <a:noFill/>
+              <a:ln>
+                <a:noFill/>
+              </a:ln>
+              <a:effectLst/>
+            </c:spPr>
             <c:txPr>
               <a:bodyPr/>
               <a:lstStyle/>
               <a:p>
                 <a:pPr>
-                  <a:defRPr b="0" i="0" strike="noStrike" sz="1100" u="none">
+                  <a:defRPr sz="1100" b="0" i="0" u="none" strike="noStrike">
                     <a:solidFill>
                       <a:srgbClr val="14213D"/>
                     </a:solidFill>
                     <a:latin typeface="+mn-lt"/>
                   </a:defRPr>
                 </a:pPr>
+                <a:endParaRPr lang="en-US"/>
               </a:p>
             </c:txPr>
             <c:showLegendKey val="0"/>
@@ -246,34 +256,38 @@
             <c:showPercent val="0"/>
             <c:showBubbleSize val="0"/>
             <c:showLeaderLines val="0"/>
+            <c:extLst>
+              <c:ext xmlns:c15="http://schemas.microsoft.com/office/drawing/2012/chart" uri="{CE6537A1-D6FC-4f65-9D91-7224C49458BB}">
+                <c15:layout/>
+                <c15:showLeaderLines val="0"/>
+              </c:ext>
+            </c:extLst>
           </c:dLbls>
           <c:cat>
-            <c:multiLvlStrRef>
+            <c:strRef>
               <c:f>Sheet1!$A$2:$A$7</c:f>
-              <c:multiLvlStrCache>
+              <c:strCache>
                 <c:ptCount val="6"/>
-                <c:lvl>
-                  <c:pt idx="0">
-                    <c:v>django-upgrade</c:v>
-                  </c:pt>
-                  <c:pt idx="1">
-                    <c:v>pyupgrade</c:v>
-                  </c:pt>
-                  <c:pt idx="2">
-                    <c:v>B: LLM only</c:v>
-                  </c:pt>
-                  <c:pt idx="3">
-                    <c:v>C: RAG</c:v>
-                  </c:pt>
-                  <c:pt idx="4">
-                    <c:v>D: ours (Gemini)</c:v>
-                  </c:pt>
-                  <c:pt idx="5">
-                    <c:v>D: offline</c:v>
-                  </c:pt>
-                </c:lvl>
-              </c:multiLvlStrCache>
-            </c:multiLvlStrRef>
+                <c:pt idx="0">
+                  <c:v>django-upgrade</c:v>
+                </c:pt>
+                <c:pt idx="1">
+                  <c:v>pyupgrade</c:v>
+                </c:pt>
+                <c:pt idx="2">
+                  <c:v>B: LLM only</c:v>
+                </c:pt>
+                <c:pt idx="3">
+                  <c:v>C: RAG</c:v>
+                </c:pt>
+                <c:pt idx="4">
+                  <c:v>D: ours (Gemini)</c:v>
+                </c:pt>
+                <c:pt idx="5">
+                  <c:v>D: offline</c:v>
+                </c:pt>
+              </c:strCache>
+            </c:strRef>
           </c:cat>
           <c:val>
             <c:numRef>
@@ -304,37 +318,19 @@
           </c:val>
         </c:ser>
         <c:dLbls>
-          <c:numFmt formatCode="0.0" sourceLinked="0"/>
-          <c:txPr>
-            <a:bodyPr/>
-            <a:lstStyle/>
-            <a:p>
-              <a:pPr>
-                <a:defRPr b="0" i="0" strike="noStrike" sz="1100" u="none">
-                  <a:solidFill>
-                    <a:srgbClr val="14213D"/>
-                  </a:solidFill>
-                  <a:latin typeface="+mn-lt"/>
-                </a:defRPr>
-              </a:pPr>
-            </a:p>
-          </c:txPr>
           <c:showLegendKey val="0"/>
           <c:showVal val="1"/>
           <c:showCatName val="0"/>
           <c:showSerName val="0"/>
           <c:showPercent val="0"/>
           <c:showBubbleSize val="0"/>
-          <c:showLeaderLines val="0"/>
         </c:dLbls>
         <c:gapWidth val="150"/>
-        <c:overlap val="0"/>
-        <c:axId val="2094734554"/>
-        <c:axId val="2094734552"/>
-        <c:axId val="2094734556"/>
+        <c:axId val="-1812634096"/>
+        <c:axId val="-1812632464"/>
       </c:barChart>
       <c:catAx>
-        <c:axId val="2094734554"/>
+        <c:axId val="-1812634096"/>
         <c:scaling>
           <c:orientation val="maxMin"/>
         </c:scaling>
@@ -368,21 +364,22 @@
             <a:endParaRPr lang="en-US"/>
           </a:p>
         </c:txPr>
-        <c:crossAx val="2094734552"/>
+        <c:crossAx val="-1812632464"/>
         <c:crosses val="autoZero"/>
         <c:auto val="1"/>
         <c:lblAlgn val="ctr"/>
+        <c:lblOffset val="100"/>
         <c:noMultiLvlLbl val="1"/>
       </c:catAx>
       <c:valAx>
-        <c:axId val="2094734552"/>
+        <c:axId val="-1812632464"/>
         <c:scaling>
           <c:orientation val="minMax"/>
           <c:max val="100"/>
           <c:min val="0"/>
         </c:scaling>
         <c:delete val="0"/>
-        <c:axPos val="b"/>
+        <c:axPos val="t"/>
         <c:majorGridlines>
           <c:spPr>
             <a:ln w="6350" cap="flat">
@@ -422,7 +419,7 @@
             <a:endParaRPr lang="en-US"/>
           </a:p>
         </c:txPr>
-        <c:crossAx val="2094734554"/>
+        <c:crossAx val="-1812634096"/>
         <c:crosses val="autoZero"/>
         <c:crossBetween val="between"/>
       </c:valAx>
@@ -436,6 +433,7 @@
     </c:plotArea>
     <c:plotVisOnly val="1"/>
     <c:dispBlanksAs val="span"/>
+    <c:showDLblsOverMax val="1"/>
   </c:chart>
   <c:spPr>
     <a:noFill/>
@@ -453,7 +451,9 @@
 <file path=ppt/charts/chart2.xml><?xml version="1.0" encoding="utf-8"?>
 <c:chartSpace xmlns:c="http://schemas.openxmlformats.org/drawingml/2006/chart" xmlns:a="http://schemas.openxmlformats.org/drawingml/2006/main" xmlns:r="http://schemas.openxmlformats.org/officeDocument/2006/relationships">
   <c:date1904 val="0"/>
+  <c:lang val="en-US"/>
   <c:roundedCorners val="1"/>
+  <c:style val="2"/>
   <c:chart>
     <c:title>
       <c:tx>
@@ -470,7 +470,7 @@
               </a:defRPr>
             </a:pPr>
             <a:r>
-              <a:rPr sz="1400" b="0" i="0" u="none" strike="noStrike">
+              <a:rPr lang="en-IN" sz="1400" b="0" i="0" u="none" strike="noStrike">
                 <a:solidFill>
                   <a:srgbClr val="14213D"/>
                 </a:solidFill>
@@ -514,18 +514,26 @@
           <c:invertIfNegative val="0"/>
           <c:dLbls>
             <c:numFmt formatCode="0.0" sourceLinked="0"/>
+            <c:spPr>
+              <a:noFill/>
+              <a:ln>
+                <a:noFill/>
+              </a:ln>
+              <a:effectLst/>
+            </c:spPr>
             <c:txPr>
               <a:bodyPr/>
               <a:lstStyle/>
               <a:p>
                 <a:pPr>
-                  <a:defRPr b="0" i="0" strike="noStrike" sz="1100" u="none">
+                  <a:defRPr sz="1100" b="0" i="0" u="none" strike="noStrike">
                     <a:solidFill>
                       <a:srgbClr val="14213D"/>
                     </a:solidFill>
                     <a:latin typeface="+mn-lt"/>
                   </a:defRPr>
                 </a:pPr>
+                <a:endParaRPr lang="en-US"/>
               </a:p>
             </c:txPr>
             <c:showLegendKey val="0"/>
@@ -535,28 +543,32 @@
             <c:showPercent val="0"/>
             <c:showBubbleSize val="0"/>
             <c:showLeaderLines val="0"/>
+            <c:extLst>
+              <c:ext xmlns:c15="http://schemas.microsoft.com/office/drawing/2012/chart" uri="{CE6537A1-D6FC-4f65-9D91-7224C49458BB}">
+                <c15:layout/>
+                <c15:showLeaderLines val="0"/>
+              </c:ext>
+            </c:extLst>
           </c:dLbls>
           <c:cat>
-            <c:multiLvlStrRef>
+            <c:strRef>
               <c:f>Sheet1!$A$2:$A$5</c:f>
-              <c:multiLvlStrCache>
+              <c:strCache>
                 <c:ptCount val="4"/>
-                <c:lvl>
-                  <c:pt idx="0">
-                    <c:v>B: LLM only</c:v>
-                  </c:pt>
-                  <c:pt idx="1">
-                    <c:v>C: RAG</c:v>
-                  </c:pt>
-                  <c:pt idx="2">
-                    <c:v>D: ours (Gemini)</c:v>
-                  </c:pt>
-                  <c:pt idx="3">
-                    <c:v>D: offline</c:v>
-                  </c:pt>
-                </c:lvl>
-              </c:multiLvlStrCache>
-            </c:multiLvlStrRef>
+                <c:pt idx="0">
+                  <c:v>B: LLM only</c:v>
+                </c:pt>
+                <c:pt idx="1">
+                  <c:v>C: RAG</c:v>
+                </c:pt>
+                <c:pt idx="2">
+                  <c:v>D: ours (Gemini)</c:v>
+                </c:pt>
+                <c:pt idx="3">
+                  <c:v>D: offline</c:v>
+                </c:pt>
+              </c:strCache>
+            </c:strRef>
           </c:cat>
           <c:val>
             <c:numRef>
@@ -581,37 +593,19 @@
           </c:val>
         </c:ser>
         <c:dLbls>
-          <c:numFmt formatCode="0.0" sourceLinked="0"/>
-          <c:txPr>
-            <a:bodyPr/>
-            <a:lstStyle/>
-            <a:p>
-              <a:pPr>
-                <a:defRPr b="0" i="0" strike="noStrike" sz="1100" u="none">
-                  <a:solidFill>
-                    <a:srgbClr val="14213D"/>
-                  </a:solidFill>
-                  <a:latin typeface="+mn-lt"/>
-                </a:defRPr>
-              </a:pPr>
-            </a:p>
-          </c:txPr>
           <c:showLegendKey val="0"/>
           <c:showVal val="1"/>
           <c:showCatName val="0"/>
           <c:showSerName val="0"/>
           <c:showPercent val="0"/>
           <c:showBubbleSize val="0"/>
-          <c:showLeaderLines val="0"/>
         </c:dLbls>
         <c:gapWidth val="150"/>
-        <c:overlap val="0"/>
-        <c:axId val="2094734554"/>
-        <c:axId val="2094734552"/>
-        <c:axId val="2094734556"/>
+        <c:axId val="-1812640080"/>
+        <c:axId val="-1812639536"/>
       </c:barChart>
       <c:catAx>
-        <c:axId val="2094734554"/>
+        <c:axId val="-1812640080"/>
         <c:scaling>
           <c:orientation val="maxMin"/>
         </c:scaling>
@@ -645,21 +639,22 @@
             <a:endParaRPr lang="en-US"/>
           </a:p>
         </c:txPr>
-        <c:crossAx val="2094734552"/>
+        <c:crossAx val="-1812639536"/>
         <c:crosses val="autoZero"/>
         <c:auto val="1"/>
         <c:lblAlgn val="ctr"/>
+        <c:lblOffset val="100"/>
         <c:noMultiLvlLbl val="1"/>
       </c:catAx>
       <c:valAx>
-        <c:axId val="2094734552"/>
+        <c:axId val="-1812639536"/>
         <c:scaling>
           <c:orientation val="minMax"/>
           <c:max val="40"/>
           <c:min val="0"/>
         </c:scaling>
         <c:delete val="0"/>
-        <c:axPos val="b"/>
+        <c:axPos val="t"/>
         <c:majorGridlines>
           <c:spPr>
             <a:ln w="6350" cap="flat">
@@ -699,7 +694,7 @@
             <a:endParaRPr lang="en-US"/>
           </a:p>
         </c:txPr>
-        <c:crossAx val="2094734554"/>
+        <c:crossAx val="-1812640080"/>
         <c:crosses val="autoZero"/>
         <c:crossBetween val="between"/>
       </c:valAx>
@@ -713,6 +708,7 @@
     </c:plotArea>
     <c:plotVisOnly val="1"/>
     <c:dispBlanksAs val="span"/>
+    <c:showDLblsOverMax val="1"/>
   </c:chart>
   <c:spPr>
     <a:noFill/>
@@ -749,234 +745,10 @@
           <a:chExt cx="0" cy="0"/>
         </a:xfrm>
       </p:grpSpPr>
-      <p:sp>
-        <p:nvSpPr>
-          <p:cNvPr id="2" name="Header Placeholder 1"/>
-          <p:cNvSpPr>
-            <a:spLocks noGrp="1"/>
-          </p:cNvSpPr>
-          <p:nvPr>
-            <p:ph type="hdr" sz="quarter"/>
-          </p:nvPr>
-        </p:nvSpPr>
-        <p:spPr>
-          <a:xfrm>
-            <a:off x="0" y="0"/>
-            <a:ext cx="2971800" cy="458788"/>
-          </a:xfrm>
-          <a:prstGeom prst="rect">
-            <a:avLst/>
-          </a:prstGeom>
-        </p:spPr>
-        <p:txBody>
-          <a:bodyPr vert="horz" lIns="91440" tIns="45720" rIns="91440" bIns="45720" rtlCol="0"/>
-          <a:lstStyle>
-            <a:lvl1pPr algn="l">
-              <a:defRPr sz="1200"/>
-            </a:lvl1pPr>
-          </a:lstStyle>
-          <a:p>
-            <a:endParaRPr lang="en-US"/>
-          </a:p>
-        </p:txBody>
-      </p:sp>
-      <p:sp>
-        <p:nvSpPr>
-          <p:cNvPr id="3" name="Date Placeholder 2"/>
-          <p:cNvSpPr>
-            <a:spLocks noGrp="1"/>
-          </p:cNvSpPr>
-          <p:nvPr>
-            <p:ph type="dt" idx="1"/>
-          </p:nvPr>
-        </p:nvSpPr>
-        <p:spPr>
-          <a:xfrm>
-            <a:off x="3884613" y="0"/>
-            <a:ext cx="2971800" cy="458788"/>
-          </a:xfrm>
-          <a:prstGeom prst="rect">
-            <a:avLst/>
-          </a:prstGeom>
-        </p:spPr>
-        <p:txBody>
-          <a:bodyPr vert="horz" lIns="91440" tIns="45720" rIns="91440" bIns="45720" rtlCol="0"/>
-          <a:lstStyle>
-            <a:lvl1pPr algn="r">
-              <a:defRPr sz="1200"/>
-            </a:lvl1pPr>
-          </a:lstStyle>
-          <a:p>
-            <a:fld id="{5282F153-3F37-0F45-9E97-73ACFA13230C}" type="datetimeFigureOut">
-              <a:rPr lang="en-US"/>
-              <a:t>7/23/19</a:t>
-            </a:fld>
-            <a:endParaRPr lang="en-US"/>
-          </a:p>
-        </p:txBody>
-      </p:sp>
-      <p:sp>
-        <p:nvSpPr>
-          <p:cNvPr id="4" name="Slide Image Placeholder 3"/>
-          <p:cNvSpPr>
-            <a:spLocks noGrp="1" noRot="1" noChangeAspect="1"/>
-          </p:cNvSpPr>
-          <p:nvPr>
-            <p:ph type="sldImg" idx="2"/>
-          </p:nvPr>
-        </p:nvSpPr>
-        <p:spPr>
-          <a:xfrm>
-            <a:off x="685800" y="1143000"/>
-            <a:ext cx="5486400" cy="3086100"/>
-          </a:xfrm>
-          <a:prstGeom prst="rect">
-            <a:avLst/>
-          </a:prstGeom>
-          <a:noFill/>
-          <a:ln w="12700">
-            <a:solidFill>
-              <a:prstClr val="black"/>
-            </a:solidFill>
-          </a:ln>
-        </p:spPr>
-        <p:txBody>
-          <a:bodyPr vert="horz" lIns="91440" tIns="45720" rIns="91440" bIns="45720" rtlCol="0" anchor="ctr"/>
-          <a:lstStyle/>
-          <a:p>
-            <a:endParaRPr lang="en-US"/>
-          </a:p>
-        </p:txBody>
-      </p:sp>
-      <p:sp>
-        <p:nvSpPr>
-          <p:cNvPr id="5" name="Notes Placeholder 4"/>
-          <p:cNvSpPr>
-            <a:spLocks noGrp="1"/>
-          </p:cNvSpPr>
-          <p:nvPr>
-            <p:ph type="body" sz="quarter" idx="3"/>
-          </p:nvPr>
-        </p:nvSpPr>
-        <p:spPr>
-          <a:xfrm>
-            <a:off x="685800" y="4400550"/>
-            <a:ext cx="5486400" cy="3600450"/>
-          </a:xfrm>
-          <a:prstGeom prst="rect">
-            <a:avLst/>
-          </a:prstGeom>
-        </p:spPr>
-        <p:txBody>
-          <a:bodyPr vert="horz" lIns="91440" tIns="45720" rIns="91440" bIns="45720" rtlCol="0"/>
-          <a:lstStyle/>
-          <a:p>
-            <a:pPr lvl="0"/>
-            <a:r>
-              <a:rPr lang="en-US"/>
-              <a:t>Click to edit Master text styles</a:t>
-            </a:r>
-          </a:p>
-          <a:p>
-            <a:pPr lvl="1"/>
-            <a:r>
-              <a:rPr lang="en-US"/>
-              <a:t>Second level</a:t>
-            </a:r>
-          </a:p>
-          <a:p>
-            <a:pPr lvl="2"/>
-            <a:r>
-              <a:rPr lang="en-US"/>
-              <a:t>Third level</a:t>
-            </a:r>
-          </a:p>
-          <a:p>
-            <a:pPr lvl="3"/>
-            <a:r>
-              <a:rPr lang="en-US"/>
-              <a:t>Fourth level</a:t>
-            </a:r>
-          </a:p>
-          <a:p>
-            <a:pPr lvl="4"/>
-            <a:r>
-              <a:rPr lang="en-US"/>
-              <a:t>Fifth level</a:t>
-            </a:r>
-          </a:p>
-        </p:txBody>
-      </p:sp>
-      <p:sp>
-        <p:nvSpPr>
-          <p:cNvPr id="6" name="Footer Placeholder 5"/>
-          <p:cNvSpPr>
-            <a:spLocks noGrp="1"/>
-          </p:cNvSpPr>
-          <p:nvPr>
-            <p:ph type="ftr" sz="quarter" idx="4"/>
-          </p:nvPr>
-        </p:nvSpPr>
-        <p:spPr>
-          <a:xfrm>
-            <a:off x="0" y="8685213"/>
-            <a:ext cx="2971800" cy="458787"/>
-          </a:xfrm>
-          <a:prstGeom prst="rect">
-            <a:avLst/>
-          </a:prstGeom>
-        </p:spPr>
-        <p:txBody>
-          <a:bodyPr vert="horz" lIns="91440" tIns="45720" rIns="91440" bIns="45720" rtlCol="0" anchor="b"/>
-          <a:lstStyle>
-            <a:lvl1pPr algn="l">
-              <a:defRPr sz="1200"/>
-            </a:lvl1pPr>
-          </a:lstStyle>
-          <a:p>
-            <a:endParaRPr lang="en-US"/>
-          </a:p>
-        </p:txBody>
-      </p:sp>
-      <p:sp>
-        <p:nvSpPr>
-          <p:cNvPr id="7" name="Slide Number Placeholder 6"/>
-          <p:cNvSpPr>
-            <a:spLocks noGrp="1"/>
-          </p:cNvSpPr>
-          <p:nvPr>
-            <p:ph type="sldNum" sz="quarter" idx="5"/>
-          </p:nvPr>
-        </p:nvSpPr>
-        <p:spPr>
-          <a:xfrm>
-            <a:off x="3884613" y="8685213"/>
-            <a:ext cx="2971800" cy="458787"/>
-          </a:xfrm>
-          <a:prstGeom prst="rect">
-            <a:avLst/>
-          </a:prstGeom>
-        </p:spPr>
-        <p:txBody>
-          <a:bodyPr vert="horz" lIns="91440" tIns="45720" rIns="91440" bIns="45720" rtlCol="0" anchor="b"/>
-          <a:lstStyle>
-            <a:lvl1pPr algn="r">
-              <a:defRPr sz="1200"/>
-            </a:lvl1pPr>
-          </a:lstStyle>
-          <a:p>
-            <a:fld id="{CE5E9CC1-C706-0F49-92D6-E571CC5EEA8F}" type="slidenum">
-              <a:rPr lang="en-US"/>
-              <a:t>‹#›</a:t>
-            </a:fld>
-            <a:endParaRPr lang="en-US"/>
-          </a:p>
-        </p:txBody>
-      </p:sp>
     </p:spTree>
     <p:extLst>
       <p:ext uri="{BB962C8B-B14F-4D97-AF65-F5344CB8AC3E}">
-        <p14:creationId xmlns:p14="http://schemas.microsoft.com/office/powerpoint/2010/main" val="1024086991"/>
+        <p14:creationId xmlns:p14="http://schemas.microsoft.com/office/powerpoint/2010/main" val="3766895956"/>
       </p:ext>
     </p:extLst>
   </p:cSld>
@@ -1124,7 +896,6 @@
               <a:rPr lang="en-US" dirty="0"/>
               <a:t>Introduce the team and the one-line idea: we find code that will break when a project moves to a newer Django, and every warning is backed by the official release note.</a:t>
             </a:r>
-            <a:endParaRPr lang="en-US" dirty="0"/>
           </a:p>
         </p:txBody>
       </p:sp>
@@ -1212,7 +983,6 @@
               <a:rPr lang="en-US" dirty="0"/>
               <a:t>Honest point: differences are small and within the confidence interval.</a:t>
             </a:r>
-            <a:endParaRPr lang="en-US" dirty="0"/>
           </a:p>
         </p:txBody>
       </p:sp>
@@ -1300,7 +1070,6 @@
               <a:rPr lang="en-US" dirty="0"/>
               <a:t>Details and links in docs/RELATED_WORK.md. Each presenter should have read the papers they mention.</a:t>
             </a:r>
-            <a:endParaRPr lang="en-US" dirty="0"/>
           </a:p>
         </p:txBody>
       </p:sp>
@@ -1388,7 +1157,6 @@
               <a:rPr lang="en-US" dirty="0"/>
               <a:t>Switch to the browser here. Keep a screen recording ready as a backup.</a:t>
             </a:r>
-            <a:endParaRPr lang="en-US" dirty="0"/>
           </a:p>
         </p:txBody>
       </p:sp>
@@ -1476,7 +1244,6 @@
               <a:rPr lang="en-US" dirty="0"/>
               <a:t>Saying the limits first makes the review easier. Likely question: why only one LLM run? Free-tier quota; all calls are cached so results reproduce exactly.</a:t>
             </a:r>
-            <a:endParaRPr lang="en-US" dirty="0"/>
           </a:p>
         </p:txBody>
       </p:sp>
@@ -1564,7 +1331,6 @@
               <a:rPr lang="en-US" dirty="0"/>
               <a:t>Replace the placeholders with the real split. Each member presents their own part and answers questions on it.</a:t>
             </a:r>
-            <a:endParaRPr lang="en-US" dirty="0"/>
           </a:p>
         </p:txBody>
       </p:sp>
@@ -1652,7 +1418,6 @@
               <a:rPr lang="en-US" dirty="0"/>
               <a:t>Close with the two numbers. Likely questions: dataset size, why Django only, cost of the validator, how labels were made.</a:t>
             </a:r>
-            <a:endParaRPr lang="en-US" dirty="0"/>
           </a:p>
         </p:txBody>
       </p:sp>
@@ -1740,7 +1505,6 @@
               <a:rPr lang="en-US" dirty="0"/>
               <a:t>Three reasons the task is hard. Mention the two published studies only at the level you have read them.</a:t>
             </a:r>
-            <a:endParaRPr lang="en-US" dirty="0"/>
           </a:p>
         </p:txBody>
       </p:sp>
@@ -1828,7 +1592,6 @@
               <a:rPr lang="en-US" dirty="0"/>
               <a:t>One sentence goal. Stress the three outputs: the line, the citation, the updated code.</a:t>
             </a:r>
-            <a:endParaRPr lang="en-US" dirty="0"/>
           </a:p>
         </p:txBody>
       </p:sp>
@@ -1916,7 +1679,6 @@
               <a:rPr lang="en-US" dirty="0"/>
               <a:t>Walk left to right. The highlighted box is the key contribution. Offline mode replaces step 3 with deterministic rules, so the tool also works without any API key.</a:t>
             </a:r>
-            <a:endParaRPr lang="en-US" dirty="0"/>
           </a:p>
         </p:txBody>
       </p:sp>
@@ -2004,7 +1766,6 @@
               <a:rPr lang="en-US" dirty="0"/>
               <a:t>Each case was run under Django 4.0.10 up to 5.1.15. The exact rule for “breaking” is in benchmark/label_by_execution.py; the owner of that part should explain it.</a:t>
             </a:r>
-            <a:endParaRPr lang="en-US" dirty="0"/>
           </a:p>
         </p:txBody>
       </p:sp>
@@ -2092,7 +1853,6 @@
               <a:rPr lang="en-US" dirty="0"/>
               <a:t>C and D share the same LLM answers, so the only difference between them is the validator.</a:t>
             </a:r>
-            <a:endParaRPr lang="en-US" dirty="0"/>
           </a:p>
         </p:txBody>
       </p:sp>
@@ -2180,7 +1940,6 @@
               <a:rPr lang="en-US" dirty="0"/>
               <a:t>Made-up = findings whose cited evidence does not support them. Be ready to say why C has slightly higher F1 than D: the validator also drops a few true findings, but it removes every unsupported one.</a:t>
             </a:r>
-            <a:endParaRPr lang="en-US" dirty="0"/>
           </a:p>
         </p:txBody>
       </p:sp>
@@ -2268,7 +2027,6 @@
               <a:rPr lang="en-US" dirty="0"/>
               <a:t>Left: accuracy. Right: only B and C produce unsupported findings; the validator brings D to zero.</a:t>
             </a:r>
-            <a:endParaRPr lang="en-US" dirty="0"/>
           </a:p>
         </p:txBody>
       </p:sp>
@@ -2356,7 +2114,6 @@
               <a:rPr lang="en-US" dirty="0"/>
               <a:t>This is the main claim of the project. Cost: recall drops from 0.92 (C) to 0.88 (D).</a:t>
             </a:r>
-            <a:endParaRPr lang="en-US" dirty="0"/>
           </a:p>
         </p:txBody>
       </p:sp>
@@ -2434,6 +2191,7 @@
         <a:solidFill>
           <a:srgbClr val="FFFFFF"/>
         </a:solidFill>
+        <a:effectLst/>
       </p:bgPr>
     </p:bg>
     <p:spTree>
@@ -2453,9 +2211,11 @@
       <p:sp>
         <p:nvSpPr>
           <p:cNvPr id="2" name="Text 0"/>
-          <p:cNvSpPr/>
+          <p:cNvSpPr>
+            <a:spLocks noGrp="1"/>
+          </p:cNvSpPr>
           <p:nvPr>
-            <p:ph idx="100" type="body" hasCustomPrompt="1"/>
+            <p:ph type="body" idx="100" hasCustomPrompt="1"/>
           </p:nvPr>
         </p:nvSpPr>
         <p:spPr>
@@ -2472,9 +2232,9 @@
         <p:txBody>
           <a:bodyPr wrap="square" rtlCol="0"/>
           <a:lstStyle>
-            <a:lvl1pPr indent="0" marL="0">
+            <a:lvl1pPr marL="0" indent="0">
               <a:buNone/>
-              <a:defRPr lang="en-US" sz="1300" spc="200" kern="0" dirty="0">
+              <a:defRPr lang="en-US" sz="1300" kern="0" spc="200" dirty="0">
                 <a:solidFill>
                   <a:srgbClr val="B5561C"/>
                 </a:solidFill>
@@ -2485,7 +2245,7 @@
             </a:lvl1pPr>
           </a:lstStyle>
           <a:p>
-            <a:pPr indent="0" marL="0">
+            <a:pPr marL="0" indent="0">
               <a:buNone/>
             </a:pPr>
             <a:endParaRPr lang="en-US" sz="1300" dirty="0"/>
@@ -2495,9 +2255,11 @@
       <p:sp>
         <p:nvSpPr>
           <p:cNvPr id="3" name="Text 0"/>
-          <p:cNvSpPr/>
+          <p:cNvSpPr>
+            <a:spLocks noGrp="1"/>
+          </p:cNvSpPr>
           <p:nvPr>
-            <p:ph idx="101" type="title" hasCustomPrompt="1"/>
+            <p:ph type="title" idx="101" hasCustomPrompt="1"/>
           </p:nvPr>
         </p:nvSpPr>
         <p:spPr>
@@ -2514,7 +2276,7 @@
         <p:txBody>
           <a:bodyPr wrap="square" rtlCol="0"/>
           <a:lstStyle>
-            <a:lvl1pPr algn="l" indent="0" marL="0">
+            <a:lvl1pPr marL="0" indent="0" algn="l">
               <a:buNone/>
               <a:defRPr lang="en-US" sz="3400" b="1" dirty="0">
                 <a:solidFill>
@@ -2527,7 +2289,7 @@
             </a:lvl1pPr>
           </a:lstStyle>
           <a:p>
-            <a:pPr algn="l" indent="0" marL="0">
+            <a:pPr marL="0" indent="0" algn="l">
               <a:buNone/>
             </a:pPr>
             <a:endParaRPr lang="en-US" sz="3400" dirty="0"/>
@@ -2554,7 +2316,7 @@
           </a:prstGeom>
           <a:extLst>
             <a:ext uri="{C572A759-6A51-4108-AA02-DFA0A04FC94B}">
-              <ma14:wrappingTextBoxFlag xmlns:ma14="http://schemas.microsoft.com/office/mac/drawingml/2011/main" val="0"/>
+              <ma14:wrappingTextBoxFlag xmlns:ma14="http://schemas.microsoft.com/office/mac/drawingml/2011/main" xmlns="" val="0"/>
             </a:ext>
           </a:extLst>
         </p:spPr>
@@ -2575,8 +2337,8 @@
           <a:p>
             <a:pPr algn="l"/>
             <a:fld id="{F7021451-1387-4CA6-816F-3879F97B5CBC}" type="slidenum">
-              <a:rPr b="0" lang="en-US"/>
-              <a:t>1002</a:t>
+              <a:rPr lang="en-US" b="0"/>
+              <a:t>‹#›</a:t>
             </a:fld>
             <a:endParaRPr lang="en-US"/>
           </a:p>
@@ -2598,6 +2360,7 @@
         <a:solidFill>
           <a:srgbClr val="14213D"/>
         </a:solidFill>
+        <a:effectLst/>
       </p:bgPr>
     </p:bg>
     <p:spTree>
@@ -2625,6 +2388,11 @@
 <file path=ppt/slideMasters/slideMaster1.xml><?xml version="1.0" encoding="utf-8"?>
 <p:sldMaster xmlns:a="http://schemas.openxmlformats.org/drawingml/2006/main" xmlns:r="http://schemas.openxmlformats.org/officeDocument/2006/relationships" xmlns:p="http://schemas.openxmlformats.org/presentationml/2006/main">
   <p:cSld>
+    <p:bg>
+      <p:bgRef idx="1001">
+        <a:schemeClr val="bg1"/>
+      </p:bgRef>
+    </p:bg>
     <p:spTree>
       <p:nvGrpSpPr>
         <p:cNvPr id="1" name=""/>
@@ -2659,7 +2427,7 @@
           </a:prstGeom>
           <a:extLst>
             <a:ext uri="{C572A759-6A51-4108-AA02-DFA0A04FC94B}">
-              <ma14:wrappingTextBoxFlag xmlns:ma14="http://schemas.microsoft.com/office/mac/drawingml/2011/main" val="0"/>
+              <ma14:wrappingTextBoxFlag xmlns:ma14="http://schemas.microsoft.com/office/mac/drawingml/2011/main" xmlns="" val="0"/>
             </a:ext>
           </a:extLst>
         </p:spPr>
@@ -2680,8 +2448,8 @@
           <a:p>
             <a:pPr algn="l"/>
             <a:fld id="{F7021451-1387-4CA6-816F-3879F97B5CBC}" type="slidenum">
-              <a:rPr b="0" lang="en-US"/>
-              <a:t>null</a:t>
+              <a:rPr lang="en-US" b="0"/>
+              <a:t>‹#›</a:t>
             </a:fld>
             <a:endParaRPr lang="en-US"/>
           </a:p>
@@ -2987,11 +2755,11 @@
           <a:bodyPr wrap="square" lIns="0" tIns="0" rIns="0" bIns="0" rtlCol="0" anchor="t"/>
           <a:lstStyle/>
           <a:p>
-            <a:pPr indent="0" marL="0">
+            <a:pPr marL="0" indent="0">
               <a:buNone/>
             </a:pPr>
             <a:r>
-              <a:rPr lang="en-US" sz="1600" spc="200" kern="0" dirty="0">
+              <a:rPr lang="en-US" sz="1600" kern="0" spc="200" dirty="0">
                 <a:solidFill>
                   <a:srgbClr val="F2A65A"/>
                 </a:solidFill>
@@ -3026,7 +2794,7 @@
           <a:bodyPr wrap="square" lIns="0" tIns="0" rIns="0" bIns="0" rtlCol="0" anchor="t"/>
           <a:lstStyle/>
           <a:p>
-            <a:pPr indent="0" marL="0">
+            <a:pPr marL="0" indent="0">
               <a:buNone/>
             </a:pPr>
             <a:r>
@@ -3065,7 +2833,7 @@
           <a:bodyPr wrap="square" lIns="0" tIns="0" rIns="0" bIns="0" rtlCol="0" anchor="t"/>
           <a:lstStyle/>
           <a:p>
-            <a:pPr indent="0" marL="0">
+            <a:pPr marL="0" indent="0">
               <a:buNone/>
             </a:pPr>
             <a:r>
@@ -3104,7 +2872,7 @@
           <a:bodyPr wrap="square" lIns="0" tIns="0" rIns="0" bIns="0" rtlCol="0" anchor="t"/>
           <a:lstStyle/>
           <a:p>
-            <a:pPr indent="0" marL="0">
+            <a:pPr marL="0" indent="0">
               <a:buNone/>
             </a:pPr>
             <a:r>
@@ -3150,9 +2918,11 @@
       <p:sp>
         <p:nvSpPr>
           <p:cNvPr id="2" name="Text 0"/>
-          <p:cNvSpPr/>
+          <p:cNvSpPr>
+            <a:spLocks noGrp="1"/>
+          </p:cNvSpPr>
           <p:nvPr>
-            <p:ph idx="100" type="body" hasCustomPrompt="1"/>
+            <p:ph type="body" idx="100" hasCustomPrompt="1"/>
           </p:nvPr>
         </p:nvSpPr>
         <p:spPr>
@@ -3170,11 +2940,11 @@
           <a:bodyPr wrap="square" lIns="0" tIns="0" rIns="0" bIns="0" rtlCol="0"/>
           <a:lstStyle/>
           <a:p>
-            <a:pPr indent="0" marL="0">
+            <a:pPr marL="0" indent="0">
               <a:buNone/>
             </a:pPr>
             <a:r>
-              <a:rPr lang="en-US" sz="1300" spc="200" kern="0" dirty="0">
+              <a:rPr lang="en-US" sz="1300" kern="0" spc="200" dirty="0">
                 <a:solidFill>
                   <a:srgbClr val="B5561C"/>
                 </a:solidFill>
@@ -3191,9 +2961,11 @@
       <p:sp>
         <p:nvSpPr>
           <p:cNvPr id="3" name="Text 0"/>
-          <p:cNvSpPr/>
+          <p:cNvSpPr>
+            <a:spLocks noGrp="1"/>
+          </p:cNvSpPr>
           <p:nvPr>
-            <p:ph idx="101" type="title" hasCustomPrompt="1"/>
+            <p:ph type="title" idx="101" hasCustomPrompt="1"/>
           </p:nvPr>
         </p:nvSpPr>
         <p:spPr>
@@ -3211,7 +2983,7 @@
           <a:bodyPr wrap="square" lIns="0" tIns="0" rIns="0" bIns="0" rtlCol="0" anchor="t"/>
           <a:lstStyle/>
           <a:p>
-            <a:pPr algn="l" indent="0" marL="0">
+            <a:pPr marL="0" indent="0" algn="l">
               <a:buNone/>
             </a:pPr>
             <a:r>
@@ -3245,7 +3017,7 @@
         </p:nvGraphicFramePr>
         <p:xfrm>
           <a:off x="548640" y="1828800"/>
-          <a:ext cx="11064240" cy="914400"/>
+          <a:ext cx="11064240" cy="2514600"/>
         </p:xfrm>
         <a:graphic>
           <a:graphicData uri="http://schemas.openxmlformats.org/drawingml/2006/table">
@@ -3263,7 +3035,7 @@
                     <a:bodyPr/>
                     <a:lstStyle/>
                     <a:p>
-                      <a:pPr algn="l" indent="0" marL="0">
+                      <a:pPr marL="0" indent="0" algn="l">
                         <a:buNone/>
                       </a:pPr>
                       <a:r>
@@ -3331,7 +3103,7 @@
                     <a:bodyPr/>
                     <a:lstStyle/>
                     <a:p>
-                      <a:pPr algn="r" indent="0" marL="0">
+                      <a:pPr marL="0" indent="0" algn="r">
                         <a:buNone/>
                       </a:pPr>
                       <a:r>
@@ -3399,7 +3171,7 @@
                     <a:bodyPr/>
                     <a:lstStyle/>
                     <a:p>
-                      <a:pPr algn="r" indent="0" marL="0">
+                      <a:pPr marL="0" indent="0" algn="r">
                         <a:buNone/>
                       </a:pPr>
                       <a:r>
@@ -3467,7 +3239,7 @@
                     <a:bodyPr/>
                     <a:lstStyle/>
                     <a:p>
-                      <a:pPr algn="r" indent="0" marL="0">
+                      <a:pPr marL="0" indent="0" algn="r">
                         <a:buNone/>
                       </a:pPr>
                       <a:r>
@@ -3537,7 +3309,7 @@
                     <a:bodyPr/>
                     <a:lstStyle/>
                     <a:p>
-                      <a:pPr algn="l" indent="0" marL="0">
+                      <a:pPr marL="0" indent="0" algn="l">
                         <a:buNone/>
                       </a:pPr>
                       <a:r>
@@ -3605,7 +3377,7 @@
                     <a:bodyPr/>
                     <a:lstStyle/>
                     <a:p>
-                      <a:pPr algn="r" indent="0" marL="0">
+                      <a:pPr marL="0" indent="0" algn="r">
                         <a:buNone/>
                       </a:pPr>
                       <a:r>
@@ -3673,7 +3445,7 @@
                     <a:bodyPr/>
                     <a:lstStyle/>
                     <a:p>
-                      <a:pPr algn="r" indent="0" marL="0">
+                      <a:pPr marL="0" indent="0" algn="r">
                         <a:buNone/>
                       </a:pPr>
                       <a:r>
@@ -3741,7 +3513,7 @@
                     <a:bodyPr/>
                     <a:lstStyle/>
                     <a:p>
-                      <a:pPr algn="r" indent="0" marL="0">
+                      <a:pPr marL="0" indent="0" algn="r">
                         <a:buNone/>
                       </a:pPr>
                       <a:r>
@@ -3811,7 +3583,7 @@
                     <a:bodyPr/>
                     <a:lstStyle/>
                     <a:p>
-                      <a:pPr algn="l" indent="0" marL="0">
+                      <a:pPr marL="0" indent="0" algn="l">
                         <a:buNone/>
                       </a:pPr>
                       <a:r>
@@ -3879,7 +3651,7 @@
                     <a:bodyPr/>
                     <a:lstStyle/>
                     <a:p>
-                      <a:pPr algn="r" indent="0" marL="0">
+                      <a:pPr marL="0" indent="0" algn="r">
                         <a:buNone/>
                       </a:pPr>
                       <a:r>
@@ -3947,7 +3719,7 @@
                     <a:bodyPr/>
                     <a:lstStyle/>
                     <a:p>
-                      <a:pPr algn="r" indent="0" marL="0">
+                      <a:pPr marL="0" indent="0" algn="r">
                         <a:buNone/>
                       </a:pPr>
                       <a:r>
@@ -4015,7 +3787,7 @@
                     <a:bodyPr/>
                     <a:lstStyle/>
                     <a:p>
-                      <a:pPr algn="r" indent="0" marL="0">
+                      <a:pPr marL="0" indent="0" algn="r">
                         <a:buNone/>
                       </a:pPr>
                       <a:r>
@@ -4085,7 +3857,7 @@
                     <a:bodyPr/>
                     <a:lstStyle/>
                     <a:p>
-                      <a:pPr algn="l" indent="0" marL="0">
+                      <a:pPr marL="0" indent="0" algn="l">
                         <a:buNone/>
                       </a:pPr>
                       <a:r>
@@ -4153,7 +3925,7 @@
                     <a:bodyPr/>
                     <a:lstStyle/>
                     <a:p>
-                      <a:pPr algn="r" indent="0" marL="0">
+                      <a:pPr marL="0" indent="0" algn="r">
                         <a:buNone/>
                       </a:pPr>
                       <a:r>
@@ -4221,7 +3993,7 @@
                     <a:bodyPr/>
                     <a:lstStyle/>
                     <a:p>
-                      <a:pPr algn="r" indent="0" marL="0">
+                      <a:pPr marL="0" indent="0" algn="r">
                         <a:buNone/>
                       </a:pPr>
                       <a:r>
@@ -4289,7 +4061,7 @@
                     <a:bodyPr/>
                     <a:lstStyle/>
                     <a:p>
-                      <a:pPr algn="r" indent="0" marL="0">
+                      <a:pPr marL="0" indent="0" algn="r">
                         <a:buNone/>
                       </a:pPr>
                       <a:r>
@@ -4359,7 +4131,7 @@
                     <a:bodyPr/>
                     <a:lstStyle/>
                     <a:p>
-                      <a:pPr algn="l" indent="0" marL="0">
+                      <a:pPr marL="0" indent="0" algn="l">
                         <a:buNone/>
                       </a:pPr>
                       <a:r>
@@ -4427,7 +4199,7 @@
                     <a:bodyPr/>
                     <a:lstStyle/>
                     <a:p>
-                      <a:pPr algn="r" indent="0" marL="0">
+                      <a:pPr marL="0" indent="0" algn="r">
                         <a:buNone/>
                       </a:pPr>
                       <a:r>
@@ -4495,7 +4267,7 @@
                     <a:bodyPr/>
                     <a:lstStyle/>
                     <a:p>
-                      <a:pPr algn="r" indent="0" marL="0">
+                      <a:pPr marL="0" indent="0" algn="r">
                         <a:buNone/>
                       </a:pPr>
                       <a:r>
@@ -4563,7 +4335,7 @@
                     <a:bodyPr/>
                     <a:lstStyle/>
                     <a:p>
-                      <a:pPr algn="r" indent="0" marL="0">
+                      <a:pPr marL="0" indent="0" algn="r">
                         <a:buNone/>
                       </a:pPr>
                       <a:r>
@@ -4652,7 +4424,7 @@
           <a:bodyPr wrap="square" lIns="0" tIns="0" rIns="0" bIns="0" rtlCol="0" anchor="t"/>
           <a:lstStyle/>
           <a:p>
-            <a:pPr indent="0" marL="0">
+            <a:pPr marL="0" indent="0">
               <a:buNone/>
             </a:pPr>
             <a:r>
@@ -4691,7 +4463,7 @@
           <a:bodyPr wrap="square" lIns="0" tIns="0" rIns="0" bIns="0" rtlCol="0" anchor="t"/>
           <a:lstStyle/>
           <a:p>
-            <a:pPr indent="0" marL="0">
+            <a:pPr marL="0" indent="0">
               <a:buNone/>
             </a:pPr>
             <a:r>
@@ -4729,7 +4501,7 @@
           </a:prstGeom>
           <a:extLst>
             <a:ext uri="{C572A759-6A51-4108-AA02-DFA0A04FC94B}">
-              <ma14:wrappingTextBoxFlag xmlns:ma14="http://schemas.microsoft.com/office/mac/drawingml/2011/main" val="0"/>
+              <ma14:wrappingTextBoxFlag xmlns:ma14="http://schemas.microsoft.com/office/mac/drawingml/2011/main" xmlns="" val="0"/>
             </a:ext>
           </a:extLst>
         </p:spPr>
@@ -4750,7 +4522,7 @@
           <a:p>
             <a:pPr algn="l"/>
             <a:fld id="{F7021451-1387-4CA6-816F-3879F97B5CBC}" type="slidenum">
-              <a:rPr b="0" lang="en-US"/>
+              <a:rPr lang="en-US" b="0"/>
               <a:t>10</a:t>
             </a:fld>
             <a:endParaRPr lang="en-US"/>
@@ -4785,9 +4557,11 @@
       <p:sp>
         <p:nvSpPr>
           <p:cNvPr id="2" name="Text 0"/>
-          <p:cNvSpPr/>
+          <p:cNvSpPr>
+            <a:spLocks noGrp="1"/>
+          </p:cNvSpPr>
           <p:nvPr>
-            <p:ph idx="100" type="body" hasCustomPrompt="1"/>
+            <p:ph type="body" idx="100" hasCustomPrompt="1"/>
           </p:nvPr>
         </p:nvSpPr>
         <p:spPr>
@@ -4805,11 +4579,11 @@
           <a:bodyPr wrap="square" lIns="0" tIns="0" rIns="0" bIns="0" rtlCol="0"/>
           <a:lstStyle/>
           <a:p>
-            <a:pPr indent="0" marL="0">
+            <a:pPr marL="0" indent="0">
               <a:buNone/>
             </a:pPr>
             <a:r>
-              <a:rPr lang="en-US" sz="1300" spc="200" kern="0" dirty="0">
+              <a:rPr lang="en-US" sz="1300" kern="0" spc="200" dirty="0">
                 <a:solidFill>
                   <a:srgbClr val="B5561C"/>
                 </a:solidFill>
@@ -4826,9 +4600,11 @@
       <p:sp>
         <p:nvSpPr>
           <p:cNvPr id="3" name="Text 0"/>
-          <p:cNvSpPr/>
+          <p:cNvSpPr>
+            <a:spLocks noGrp="1"/>
+          </p:cNvSpPr>
           <p:nvPr>
-            <p:ph idx="101" type="title" hasCustomPrompt="1"/>
+            <p:ph type="title" idx="101" hasCustomPrompt="1"/>
           </p:nvPr>
         </p:nvSpPr>
         <p:spPr>
@@ -4846,7 +4622,7 @@
           <a:bodyPr wrap="square" lIns="0" tIns="0" rIns="0" bIns="0" rtlCol="0" anchor="t"/>
           <a:lstStyle/>
           <a:p>
-            <a:pPr algn="l" indent="0" marL="0">
+            <a:pPr marL="0" indent="0" algn="l">
               <a:buNone/>
             </a:pPr>
             <a:r>
@@ -4880,7 +4656,7 @@
         </p:nvGraphicFramePr>
         <p:xfrm>
           <a:off x="548640" y="1691640"/>
-          <a:ext cx="11064240" cy="914400"/>
+          <a:ext cx="11064240" cy="3657600"/>
         </p:xfrm>
         <a:graphic>
           <a:graphicData uri="http://schemas.openxmlformats.org/drawingml/2006/table">
@@ -4899,7 +4675,7 @@
                     <a:bodyPr/>
                     <a:lstStyle/>
                     <a:p>
-                      <a:pPr algn="l" indent="0" marL="0">
+                      <a:pPr marL="0" indent="0" algn="l">
                         <a:buNone/>
                       </a:pPr>
                       <a:r>
@@ -4967,7 +4743,7 @@
                     <a:bodyPr/>
                     <a:lstStyle/>
                     <a:p>
-                      <a:pPr algn="l" indent="0" marL="0">
+                      <a:pPr marL="0" indent="0" algn="l">
                         <a:buNone/>
                       </a:pPr>
                       <a:r>
@@ -5035,7 +4811,7 @@
                     <a:bodyPr/>
                     <a:lstStyle/>
                     <a:p>
-                      <a:pPr algn="l" indent="0" marL="0">
+                      <a:pPr marL="0" indent="0" algn="l">
                         <a:buNone/>
                       </a:pPr>
                       <a:r>
@@ -5103,7 +4879,7 @@
                     <a:bodyPr/>
                     <a:lstStyle/>
                     <a:p>
-                      <a:pPr algn="l" indent="0" marL="0">
+                      <a:pPr marL="0" indent="0" algn="l">
                         <a:buNone/>
                       </a:pPr>
                       <a:r>
@@ -5171,7 +4947,7 @@
                     <a:bodyPr/>
                     <a:lstStyle/>
                     <a:p>
-                      <a:pPr algn="l" indent="0" marL="0">
+                      <a:pPr marL="0" indent="0" algn="l">
                         <a:buNone/>
                       </a:pPr>
                       <a:r>
@@ -5241,7 +5017,7 @@
                     <a:bodyPr/>
                     <a:lstStyle/>
                     <a:p>
-                      <a:pPr algn="l" indent="0" marL="0">
+                      <a:pPr marL="0" indent="0" algn="l">
                         <a:buNone/>
                       </a:pPr>
                       <a:r>
@@ -5309,7 +5085,7 @@
                     <a:bodyPr/>
                     <a:lstStyle/>
                     <a:p>
-                      <a:pPr algn="l" indent="0" marL="0">
+                      <a:pPr marL="0" indent="0" algn="l">
                         <a:buNone/>
                       </a:pPr>
                       <a:r>
@@ -5377,7 +5153,7 @@
                     <a:bodyPr/>
                     <a:lstStyle/>
                     <a:p>
-                      <a:pPr algn="l" indent="0" marL="0">
+                      <a:pPr marL="0" indent="0" algn="l">
                         <a:buNone/>
                       </a:pPr>
                       <a:r>
@@ -5445,7 +5221,7 @@
                     <a:bodyPr/>
                     <a:lstStyle/>
                     <a:p>
-                      <a:pPr algn="l" indent="0" marL="0">
+                      <a:pPr marL="0" indent="0" algn="l">
                         <a:buNone/>
                       </a:pPr>
                       <a:r>
@@ -5513,7 +5289,7 @@
                     <a:bodyPr/>
                     <a:lstStyle/>
                     <a:p>
-                      <a:pPr algn="l" indent="0" marL="0">
+                      <a:pPr marL="0" indent="0" algn="l">
                         <a:buNone/>
                       </a:pPr>
                       <a:r>
@@ -5583,7 +5359,7 @@
                     <a:bodyPr/>
                     <a:lstStyle/>
                     <a:p>
-                      <a:pPr algn="l" indent="0" marL="0">
+                      <a:pPr marL="0" indent="0" algn="l">
                         <a:buNone/>
                       </a:pPr>
                       <a:r>
@@ -5651,7 +5427,7 @@
                     <a:bodyPr/>
                     <a:lstStyle/>
                     <a:p>
-                      <a:pPr algn="l" indent="0" marL="0">
+                      <a:pPr marL="0" indent="0" algn="l">
                         <a:buNone/>
                       </a:pPr>
                       <a:r>
@@ -5719,7 +5495,7 @@
                     <a:bodyPr/>
                     <a:lstStyle/>
                     <a:p>
-                      <a:pPr algn="l" indent="0" marL="0">
+                      <a:pPr marL="0" indent="0" algn="l">
                         <a:buNone/>
                       </a:pPr>
                       <a:r>
@@ -5787,7 +5563,7 @@
                     <a:bodyPr/>
                     <a:lstStyle/>
                     <a:p>
-                      <a:pPr algn="l" indent="0" marL="0">
+                      <a:pPr marL="0" indent="0" algn="l">
                         <a:buNone/>
                       </a:pPr>
                       <a:r>
@@ -5855,7 +5631,7 @@
                     <a:bodyPr/>
                     <a:lstStyle/>
                     <a:p>
-                      <a:pPr algn="l" indent="0" marL="0">
+                      <a:pPr marL="0" indent="0" algn="l">
                         <a:buNone/>
                       </a:pPr>
                       <a:r>
@@ -5925,7 +5701,7 @@
                     <a:bodyPr/>
                     <a:lstStyle/>
                     <a:p>
-                      <a:pPr algn="l" indent="0" marL="0">
+                      <a:pPr marL="0" indent="0" algn="l">
                         <a:buNone/>
                       </a:pPr>
                       <a:r>
@@ -5993,7 +5769,7 @@
                     <a:bodyPr/>
                     <a:lstStyle/>
                     <a:p>
-                      <a:pPr algn="l" indent="0" marL="0">
+                      <a:pPr marL="0" indent="0" algn="l">
                         <a:buNone/>
                       </a:pPr>
                       <a:r>
@@ -6061,7 +5837,7 @@
                     <a:bodyPr/>
                     <a:lstStyle/>
                     <a:p>
-                      <a:pPr algn="l" indent="0" marL="0">
+                      <a:pPr marL="0" indent="0" algn="l">
                         <a:buNone/>
                       </a:pPr>
                       <a:r>
@@ -6129,7 +5905,7 @@
                     <a:bodyPr/>
                     <a:lstStyle/>
                     <a:p>
-                      <a:pPr algn="l" indent="0" marL="0">
+                      <a:pPr marL="0" indent="0" algn="l">
                         <a:buNone/>
                       </a:pPr>
                       <a:r>
@@ -6197,7 +5973,7 @@
                     <a:bodyPr/>
                     <a:lstStyle/>
                     <a:p>
-                      <a:pPr algn="l" indent="0" marL="0">
+                      <a:pPr marL="0" indent="0" algn="l">
                         <a:buNone/>
                       </a:pPr>
                       <a:r>
@@ -6267,7 +6043,7 @@
                     <a:bodyPr/>
                     <a:lstStyle/>
                     <a:p>
-                      <a:pPr algn="l" indent="0" marL="0">
+                      <a:pPr marL="0" indent="0" algn="l">
                         <a:buNone/>
                       </a:pPr>
                       <a:r>
@@ -6335,7 +6111,7 @@
                     <a:bodyPr/>
                     <a:lstStyle/>
                     <a:p>
-                      <a:pPr algn="l" indent="0" marL="0">
+                      <a:pPr marL="0" indent="0" algn="l">
                         <a:buNone/>
                       </a:pPr>
                       <a:r>
@@ -6403,7 +6179,7 @@
                     <a:bodyPr/>
                     <a:lstStyle/>
                     <a:p>
-                      <a:pPr algn="l" indent="0" marL="0">
+                      <a:pPr marL="0" indent="0" algn="l">
                         <a:buNone/>
                       </a:pPr>
                       <a:r>
@@ -6471,7 +6247,7 @@
                     <a:bodyPr/>
                     <a:lstStyle/>
                     <a:p>
-                      <a:pPr algn="l" indent="0" marL="0">
+                      <a:pPr marL="0" indent="0" algn="l">
                         <a:buNone/>
                       </a:pPr>
                       <a:r>
@@ -6539,7 +6315,7 @@
                     <a:bodyPr/>
                     <a:lstStyle/>
                     <a:p>
-                      <a:pPr algn="l" indent="0" marL="0">
+                      <a:pPr marL="0" indent="0" algn="l">
                         <a:buNone/>
                       </a:pPr>
                       <a:r>
@@ -6609,7 +6385,7 @@
                     <a:bodyPr/>
                     <a:lstStyle/>
                     <a:p>
-                      <a:pPr algn="l" indent="0" marL="0">
+                      <a:pPr marL="0" indent="0" algn="l">
                         <a:buNone/>
                       </a:pPr>
                       <a:r>
@@ -6677,7 +6453,7 @@
                     <a:bodyPr/>
                     <a:lstStyle/>
                     <a:p>
-                      <a:pPr algn="l" indent="0" marL="0">
+                      <a:pPr marL="0" indent="0" algn="l">
                         <a:buNone/>
                       </a:pPr>
                       <a:r>
@@ -6745,7 +6521,7 @@
                     <a:bodyPr/>
                     <a:lstStyle/>
                     <a:p>
-                      <a:pPr algn="l" indent="0" marL="0">
+                      <a:pPr marL="0" indent="0" algn="l">
                         <a:buNone/>
                       </a:pPr>
                       <a:r>
@@ -6813,7 +6589,7 @@
                     <a:bodyPr/>
                     <a:lstStyle/>
                     <a:p>
-                      <a:pPr algn="l" indent="0" marL="0">
+                      <a:pPr marL="0" indent="0" algn="l">
                         <a:buNone/>
                       </a:pPr>
                       <a:r>
@@ -6881,7 +6657,7 @@
                     <a:bodyPr/>
                     <a:lstStyle/>
                     <a:p>
-                      <a:pPr algn="l" indent="0" marL="0">
+                      <a:pPr marL="0" indent="0" algn="l">
                         <a:buNone/>
                       </a:pPr>
                       <a:r>
@@ -6951,7 +6727,7 @@
                     <a:bodyPr/>
                     <a:lstStyle/>
                     <a:p>
-                      <a:pPr algn="l" indent="0" marL="0">
+                      <a:pPr marL="0" indent="0" algn="l">
                         <a:buNone/>
                       </a:pPr>
                       <a:r>
@@ -7019,7 +6795,7 @@
                     <a:bodyPr/>
                     <a:lstStyle/>
                     <a:p>
-                      <a:pPr algn="l" indent="0" marL="0">
+                      <a:pPr marL="0" indent="0" algn="l">
                         <a:buNone/>
                       </a:pPr>
                       <a:r>
@@ -7087,7 +6863,7 @@
                     <a:bodyPr/>
                     <a:lstStyle/>
                     <a:p>
-                      <a:pPr algn="l" indent="0" marL="0">
+                      <a:pPr marL="0" indent="0" algn="l">
                         <a:buNone/>
                       </a:pPr>
                       <a:r>
@@ -7155,7 +6931,7 @@
                     <a:bodyPr/>
                     <a:lstStyle/>
                     <a:p>
-                      <a:pPr algn="l" indent="0" marL="0">
+                      <a:pPr marL="0" indent="0" algn="l">
                         <a:buNone/>
                       </a:pPr>
                       <a:r>
@@ -7223,7 +6999,7 @@
                     <a:bodyPr/>
                     <a:lstStyle/>
                     <a:p>
-                      <a:pPr algn="l" indent="0" marL="0">
+                      <a:pPr marL="0" indent="0" algn="l">
                         <a:buNone/>
                       </a:pPr>
                       <a:r>
@@ -7293,7 +7069,7 @@
                     <a:bodyPr/>
                     <a:lstStyle/>
                     <a:p>
-                      <a:pPr algn="l" indent="0" marL="0">
+                      <a:pPr marL="0" indent="0" algn="l">
                         <a:buNone/>
                       </a:pPr>
                       <a:r>
@@ -7361,7 +7137,7 @@
                     <a:bodyPr/>
                     <a:lstStyle/>
                     <a:p>
-                      <a:pPr algn="l" indent="0" marL="0">
+                      <a:pPr marL="0" indent="0" algn="l">
                         <a:buNone/>
                       </a:pPr>
                       <a:r>
@@ -7429,7 +7205,7 @@
                     <a:bodyPr/>
                     <a:lstStyle/>
                     <a:p>
-                      <a:pPr algn="l" indent="0" marL="0">
+                      <a:pPr marL="0" indent="0" algn="l">
                         <a:buNone/>
                       </a:pPr>
                       <a:r>
@@ -7497,7 +7273,7 @@
                     <a:bodyPr/>
                     <a:lstStyle/>
                     <a:p>
-                      <a:pPr algn="l" indent="0" marL="0">
+                      <a:pPr marL="0" indent="0" algn="l">
                         <a:buNone/>
                       </a:pPr>
                       <a:r>
@@ -7565,7 +7341,7 @@
                     <a:bodyPr/>
                     <a:lstStyle/>
                     <a:p>
-                      <a:pPr algn="l" indent="0" marL="0">
+                      <a:pPr marL="0" indent="0" algn="l">
                         <a:buNone/>
                       </a:pPr>
                       <a:r>
@@ -7654,7 +7430,7 @@
           <a:bodyPr wrap="square" lIns="0" tIns="0" rIns="0" bIns="0" rtlCol="0" anchor="t"/>
           <a:lstStyle/>
           <a:p>
-            <a:pPr indent="0" marL="0">
+            <a:pPr marL="0" indent="0">
               <a:buNone/>
             </a:pPr>
             <a:r>
@@ -7692,7 +7468,7 @@
           </a:prstGeom>
           <a:extLst>
             <a:ext uri="{C572A759-6A51-4108-AA02-DFA0A04FC94B}">
-              <ma14:wrappingTextBoxFlag xmlns:ma14="http://schemas.microsoft.com/office/mac/drawingml/2011/main" val="0"/>
+              <ma14:wrappingTextBoxFlag xmlns:ma14="http://schemas.microsoft.com/office/mac/drawingml/2011/main" xmlns="" val="0"/>
             </a:ext>
           </a:extLst>
         </p:spPr>
@@ -7713,7 +7489,7 @@
           <a:p>
             <a:pPr algn="l"/>
             <a:fld id="{F7021451-1387-4CA6-816F-3879F97B5CBC}" type="slidenum">
-              <a:rPr b="0" lang="en-US"/>
+              <a:rPr lang="en-US" b="0"/>
               <a:t>11</a:t>
             </a:fld>
             <a:endParaRPr lang="en-US"/>
@@ -7748,9 +7524,11 @@
       <p:sp>
         <p:nvSpPr>
           <p:cNvPr id="2" name="Text 0"/>
-          <p:cNvSpPr/>
+          <p:cNvSpPr>
+            <a:spLocks noGrp="1"/>
+          </p:cNvSpPr>
           <p:nvPr>
-            <p:ph idx="100" type="body" hasCustomPrompt="1"/>
+            <p:ph type="body" idx="100" hasCustomPrompt="1"/>
           </p:nvPr>
         </p:nvSpPr>
         <p:spPr>
@@ -7768,11 +7546,11 @@
           <a:bodyPr wrap="square" lIns="0" tIns="0" rIns="0" bIns="0" rtlCol="0"/>
           <a:lstStyle/>
           <a:p>
-            <a:pPr indent="0" marL="0">
+            <a:pPr marL="0" indent="0">
               <a:buNone/>
             </a:pPr>
             <a:r>
-              <a:rPr lang="en-US" sz="1300" spc="200" kern="0" dirty="0">
+              <a:rPr lang="en-US" sz="1300" kern="0" spc="200" dirty="0">
                 <a:solidFill>
                   <a:srgbClr val="B5561C"/>
                 </a:solidFill>
@@ -7789,9 +7567,11 @@
       <p:sp>
         <p:nvSpPr>
           <p:cNvPr id="3" name="Text 0"/>
-          <p:cNvSpPr/>
+          <p:cNvSpPr>
+            <a:spLocks noGrp="1"/>
+          </p:cNvSpPr>
           <p:nvPr>
-            <p:ph idx="101" type="title" hasCustomPrompt="1"/>
+            <p:ph type="title" idx="101" hasCustomPrompt="1"/>
           </p:nvPr>
         </p:nvSpPr>
         <p:spPr>
@@ -7809,7 +7589,7 @@
           <a:bodyPr wrap="square" lIns="0" tIns="0" rIns="0" bIns="0" rtlCol="0" anchor="t"/>
           <a:lstStyle/>
           <a:p>
-            <a:pPr algn="l" indent="0" marL="0">
+            <a:pPr marL="0" indent="0" algn="l">
               <a:buNone/>
             </a:pPr>
             <a:r>
@@ -7900,7 +7680,7 @@
           <a:bodyPr wrap="square" lIns="0" tIns="0" rIns="0" bIns="0" rtlCol="0" anchor="ctr"/>
           <a:lstStyle/>
           <a:p>
-            <a:pPr algn="ctr" indent="0" marL="0">
+            <a:pPr marL="0" indent="0" algn="ctr">
               <a:buNone/>
             </a:pPr>
             <a:r>
@@ -7939,7 +7719,7 @@
           <a:bodyPr wrap="square" lIns="0" tIns="0" rIns="0" bIns="0" rtlCol="0" anchor="t"/>
           <a:lstStyle/>
           <a:p>
-            <a:pPr indent="0" marL="0">
+            <a:pPr marL="0" indent="0">
               <a:buNone/>
             </a:pPr>
             <a:r>
@@ -7978,7 +7758,7 @@
           <a:bodyPr wrap="square" lIns="0" tIns="0" rIns="0" bIns="0" rtlCol="0" anchor="t"/>
           <a:lstStyle/>
           <a:p>
-            <a:pPr indent="0" marL="0">
+            <a:pPr marL="0" indent="0">
               <a:buNone/>
             </a:pPr>
             <a:r>
@@ -8069,7 +7849,7 @@
           <a:bodyPr wrap="square" lIns="0" tIns="0" rIns="0" bIns="0" rtlCol="0" anchor="ctr"/>
           <a:lstStyle/>
           <a:p>
-            <a:pPr algn="ctr" indent="0" marL="0">
+            <a:pPr marL="0" indent="0" algn="ctr">
               <a:buNone/>
             </a:pPr>
             <a:r>
@@ -8108,7 +7888,7 @@
           <a:bodyPr wrap="square" lIns="0" tIns="0" rIns="0" bIns="0" rtlCol="0" anchor="t"/>
           <a:lstStyle/>
           <a:p>
-            <a:pPr indent="0" marL="0">
+            <a:pPr marL="0" indent="0">
               <a:buNone/>
             </a:pPr>
             <a:r>
@@ -8147,7 +7927,7 @@
           <a:bodyPr wrap="square" lIns="0" tIns="0" rIns="0" bIns="0" rtlCol="0" anchor="t"/>
           <a:lstStyle/>
           <a:p>
-            <a:pPr indent="0" marL="0">
+            <a:pPr marL="0" indent="0">
               <a:buNone/>
             </a:pPr>
             <a:r>
@@ -8238,7 +8018,7 @@
           <a:bodyPr wrap="square" lIns="0" tIns="0" rIns="0" bIns="0" rtlCol="0" anchor="ctr"/>
           <a:lstStyle/>
           <a:p>
-            <a:pPr algn="ctr" indent="0" marL="0">
+            <a:pPr marL="0" indent="0" algn="ctr">
               <a:buNone/>
             </a:pPr>
             <a:r>
@@ -8277,7 +8057,7 @@
           <a:bodyPr wrap="square" lIns="0" tIns="0" rIns="0" bIns="0" rtlCol="0" anchor="t"/>
           <a:lstStyle/>
           <a:p>
-            <a:pPr indent="0" marL="0">
+            <a:pPr marL="0" indent="0">
               <a:buNone/>
             </a:pPr>
             <a:r>
@@ -8316,7 +8096,7 @@
           <a:bodyPr wrap="square" lIns="0" tIns="0" rIns="0" bIns="0" rtlCol="0" anchor="t"/>
           <a:lstStyle/>
           <a:p>
-            <a:pPr indent="0" marL="0">
+            <a:pPr marL="0" indent="0">
               <a:buNone/>
             </a:pPr>
             <a:r>
@@ -8407,7 +8187,7 @@
           <a:bodyPr wrap="square" lIns="0" tIns="0" rIns="0" bIns="0" rtlCol="0" anchor="ctr"/>
           <a:lstStyle/>
           <a:p>
-            <a:pPr algn="ctr" indent="0" marL="0">
+            <a:pPr marL="0" indent="0" algn="ctr">
               <a:buNone/>
             </a:pPr>
             <a:r>
@@ -8446,7 +8226,7 @@
           <a:bodyPr wrap="square" lIns="0" tIns="0" rIns="0" bIns="0" rtlCol="0" anchor="t"/>
           <a:lstStyle/>
           <a:p>
-            <a:pPr indent="0" marL="0">
+            <a:pPr marL="0" indent="0">
               <a:buNone/>
             </a:pPr>
             <a:r>
@@ -8485,7 +8265,7 @@
           <a:bodyPr wrap="square" lIns="0" tIns="0" rIns="0" bIns="0" rtlCol="0" anchor="t"/>
           <a:lstStyle/>
           <a:p>
-            <a:pPr indent="0" marL="0">
+            <a:pPr marL="0" indent="0">
               <a:buNone/>
             </a:pPr>
             <a:r>
@@ -8524,7 +8304,7 @@
           <a:bodyPr wrap="square" lIns="0" tIns="0" rIns="0" bIns="0" rtlCol="0" anchor="t"/>
           <a:lstStyle/>
           <a:p>
-            <a:pPr indent="0" marL="0">
+            <a:pPr marL="0" indent="0">
               <a:buNone/>
             </a:pPr>
             <a:r>
@@ -8538,9 +8318,6 @@
               </a:rPr>
               <a:t>Stack: FastAPI + JWT, React + Vite, SQLite. CLI: </a:t>
             </a:r>
-            <a:pPr indent="0" marL="0">
-              <a:buNone/>
-            </a:pPr>
             <a:r>
               <a:rPr lang="en-US" sz="1600" dirty="0">
                 <a:solidFill>
@@ -8552,9 +8329,6 @@
               </a:rPr>
               <a:t>codemigrate scan --write-fixed</a:t>
             </a:r>
-            <a:pPr indent="0" marL="0">
-              <a:buNone/>
-            </a:pPr>
             <a:r>
               <a:rPr lang="en-US" sz="1600" dirty="0">
                 <a:solidFill>
@@ -8591,7 +8365,7 @@
           <a:bodyPr wrap="square" lIns="0" tIns="0" rIns="0" bIns="0" rtlCol="0" anchor="t"/>
           <a:lstStyle/>
           <a:p>
-            <a:pPr indent="0" marL="0">
+            <a:pPr marL="0" indent="0">
               <a:buNone/>
             </a:pPr>
             <a:r>
@@ -8611,7 +8385,7 @@
       </p:sp>
       <p:sp>
         <p:nvSpPr>
-          <p:cNvPr id="25" name="Slide Number Placeholder 0"/>
+          <p:cNvPr id="26" name="Slide Number Placeholder 0"/>
           <p:cNvSpPr>
             <a:spLocks noGrp="1"/>
           </p:cNvSpPr>
@@ -8629,7 +8403,7 @@
           </a:prstGeom>
           <a:extLst>
             <a:ext uri="{C572A759-6A51-4108-AA02-DFA0A04FC94B}">
-              <ma14:wrappingTextBoxFlag xmlns:ma14="http://schemas.microsoft.com/office/mac/drawingml/2011/main" val="0"/>
+              <ma14:wrappingTextBoxFlag xmlns:ma14="http://schemas.microsoft.com/office/mac/drawingml/2011/main" xmlns="" val="0"/>
             </a:ext>
           </a:extLst>
         </p:spPr>
@@ -8650,7 +8424,7 @@
           <a:p>
             <a:pPr algn="l"/>
             <a:fld id="{F7021451-1387-4CA6-816F-3879F97B5CBC}" type="slidenum">
-              <a:rPr b="0" lang="en-US"/>
+              <a:rPr lang="en-US" b="0"/>
               <a:t>12</a:t>
             </a:fld>
             <a:endParaRPr lang="en-US"/>
@@ -8685,9 +8459,11 @@
       <p:sp>
         <p:nvSpPr>
           <p:cNvPr id="2" name="Text 0"/>
-          <p:cNvSpPr/>
+          <p:cNvSpPr>
+            <a:spLocks noGrp="1"/>
+          </p:cNvSpPr>
           <p:nvPr>
-            <p:ph idx="100" type="body" hasCustomPrompt="1"/>
+            <p:ph type="body" idx="100" hasCustomPrompt="1"/>
           </p:nvPr>
         </p:nvSpPr>
         <p:spPr>
@@ -8705,11 +8481,11 @@
           <a:bodyPr wrap="square" lIns="0" tIns="0" rIns="0" bIns="0" rtlCol="0"/>
           <a:lstStyle/>
           <a:p>
-            <a:pPr indent="0" marL="0">
+            <a:pPr marL="0" indent="0">
               <a:buNone/>
             </a:pPr>
             <a:r>
-              <a:rPr lang="en-US" sz="1300" spc="200" kern="0" dirty="0">
+              <a:rPr lang="en-US" sz="1300" kern="0" spc="200" dirty="0">
                 <a:solidFill>
                   <a:srgbClr val="B5561C"/>
                 </a:solidFill>
@@ -8726,9 +8502,11 @@
       <p:sp>
         <p:nvSpPr>
           <p:cNvPr id="3" name="Text 0"/>
-          <p:cNvSpPr/>
+          <p:cNvSpPr>
+            <a:spLocks noGrp="1"/>
+          </p:cNvSpPr>
           <p:nvPr>
-            <p:ph idx="101" type="title" hasCustomPrompt="1"/>
+            <p:ph type="title" idx="101" hasCustomPrompt="1"/>
           </p:nvPr>
         </p:nvSpPr>
         <p:spPr>
@@ -8746,7 +8524,7 @@
           <a:bodyPr wrap="square" lIns="0" tIns="0" rIns="0" bIns="0" rtlCol="0" anchor="t"/>
           <a:lstStyle/>
           <a:p>
-            <a:pPr algn="l" indent="0" marL="0">
+            <a:pPr marL="0" indent="0" algn="l">
               <a:buNone/>
             </a:pPr>
             <a:r>
@@ -8812,7 +8590,7 @@
           <a:bodyPr wrap="square" lIns="0" tIns="0" rIns="0" bIns="0" rtlCol="0" anchor="t"/>
           <a:lstStyle/>
           <a:p>
-            <a:pPr indent="0" marL="0">
+            <a:pPr marL="0" indent="0">
               <a:buNone/>
             </a:pPr>
             <a:r>
@@ -8984,7 +8762,7 @@
           <a:bodyPr wrap="square" lIns="0" tIns="0" rIns="0" bIns="0" rtlCol="0" anchor="t"/>
           <a:lstStyle/>
           <a:p>
-            <a:pPr indent="0" marL="0">
+            <a:pPr marL="0" indent="0">
               <a:buNone/>
             </a:pPr>
             <a:r>
@@ -9128,7 +8906,7 @@
           </a:prstGeom>
           <a:extLst>
             <a:ext uri="{C572A759-6A51-4108-AA02-DFA0A04FC94B}">
-              <ma14:wrappingTextBoxFlag xmlns:ma14="http://schemas.microsoft.com/office/mac/drawingml/2011/main" val="0"/>
+              <ma14:wrappingTextBoxFlag xmlns:ma14="http://schemas.microsoft.com/office/mac/drawingml/2011/main" xmlns="" val="0"/>
             </a:ext>
           </a:extLst>
         </p:spPr>
@@ -9149,7 +8927,7 @@
           <a:p>
             <a:pPr algn="l"/>
             <a:fld id="{F7021451-1387-4CA6-816F-3879F97B5CBC}" type="slidenum">
-              <a:rPr b="0" lang="en-US"/>
+              <a:rPr lang="en-US" b="0"/>
               <a:t>13</a:t>
             </a:fld>
             <a:endParaRPr lang="en-US"/>
@@ -9184,9 +8962,11 @@
       <p:sp>
         <p:nvSpPr>
           <p:cNvPr id="2" name="Text 0"/>
-          <p:cNvSpPr/>
+          <p:cNvSpPr>
+            <a:spLocks noGrp="1"/>
+          </p:cNvSpPr>
           <p:nvPr>
-            <p:ph idx="100" type="body" hasCustomPrompt="1"/>
+            <p:ph type="body" idx="100" hasCustomPrompt="1"/>
           </p:nvPr>
         </p:nvSpPr>
         <p:spPr>
@@ -9204,11 +8984,11 @@
           <a:bodyPr wrap="square" lIns="0" tIns="0" rIns="0" bIns="0" rtlCol="0"/>
           <a:lstStyle/>
           <a:p>
-            <a:pPr indent="0" marL="0">
+            <a:pPr marL="0" indent="0">
               <a:buNone/>
             </a:pPr>
             <a:r>
-              <a:rPr lang="en-US" sz="1300" spc="200" kern="0" dirty="0">
+              <a:rPr lang="en-US" sz="1300" kern="0" spc="200" dirty="0">
                 <a:solidFill>
                   <a:srgbClr val="B5561C"/>
                 </a:solidFill>
@@ -9225,9 +9005,11 @@
       <p:sp>
         <p:nvSpPr>
           <p:cNvPr id="3" name="Text 0"/>
-          <p:cNvSpPr/>
+          <p:cNvSpPr>
+            <a:spLocks noGrp="1"/>
+          </p:cNvSpPr>
           <p:nvPr>
-            <p:ph idx="101" type="title" hasCustomPrompt="1"/>
+            <p:ph type="title" idx="101" hasCustomPrompt="1"/>
           </p:nvPr>
         </p:nvSpPr>
         <p:spPr>
@@ -9245,7 +9027,7 @@
           <a:bodyPr wrap="square" lIns="0" tIns="0" rIns="0" bIns="0" rtlCol="0" anchor="t"/>
           <a:lstStyle/>
           <a:p>
-            <a:pPr algn="l" indent="0" marL="0">
+            <a:pPr marL="0" indent="0" algn="l">
               <a:buNone/>
             </a:pPr>
             <a:r>
@@ -9295,7 +9077,7 @@
                     <a:bodyPr/>
                     <a:lstStyle/>
                     <a:p>
-                      <a:pPr algn="l" indent="0" marL="0">
+                      <a:pPr marL="0" indent="0" algn="l">
                         <a:buNone/>
                       </a:pPr>
                       <a:r>
@@ -9363,7 +9145,7 @@
                     <a:bodyPr/>
                     <a:lstStyle/>
                     <a:p>
-                      <a:pPr algn="l" indent="0" marL="0">
+                      <a:pPr marL="0" indent="0" algn="l">
                         <a:buNone/>
                       </a:pPr>
                       <a:r>
@@ -9433,7 +9215,7 @@
                     <a:bodyPr/>
                     <a:lstStyle/>
                     <a:p>
-                      <a:pPr algn="l" indent="0" marL="0">
+                      <a:pPr marL="0" indent="0" algn="l">
                         <a:buNone/>
                       </a:pPr>
                       <a:r>
@@ -9501,7 +9283,7 @@
                     <a:bodyPr/>
                     <a:lstStyle/>
                     <a:p>
-                      <a:pPr algn="l" indent="0" marL="0">
+                      <a:pPr marL="0" indent="0" algn="l">
                         <a:buNone/>
                       </a:pPr>
                       <a:r>
@@ -9571,7 +9353,7 @@
                     <a:bodyPr/>
                     <a:lstStyle/>
                     <a:p>
-                      <a:pPr algn="l" indent="0" marL="0">
+                      <a:pPr marL="0" indent="0" algn="l">
                         <a:buNone/>
                       </a:pPr>
                       <a:r>
@@ -9639,7 +9421,7 @@
                     <a:bodyPr/>
                     <a:lstStyle/>
                     <a:p>
-                      <a:pPr algn="l" indent="0" marL="0">
+                      <a:pPr marL="0" indent="0" algn="l">
                         <a:buNone/>
                       </a:pPr>
                       <a:r>
@@ -9709,7 +9491,7 @@
                     <a:bodyPr/>
                     <a:lstStyle/>
                     <a:p>
-                      <a:pPr algn="l" indent="0" marL="0">
+                      <a:pPr marL="0" indent="0" algn="l">
                         <a:buNone/>
                       </a:pPr>
                       <a:r>
@@ -9777,7 +9559,7 @@
                     <a:bodyPr/>
                     <a:lstStyle/>
                     <a:p>
-                      <a:pPr algn="l" indent="0" marL="0">
+                      <a:pPr marL="0" indent="0" algn="l">
                         <a:buNone/>
                       </a:pPr>
                       <a:r>
@@ -9847,7 +9629,7 @@
                     <a:bodyPr/>
                     <a:lstStyle/>
                     <a:p>
-                      <a:pPr algn="l" indent="0" marL="0">
+                      <a:pPr marL="0" indent="0" algn="l">
                         <a:buNone/>
                       </a:pPr>
                       <a:r>
@@ -9915,7 +9697,7 @@
                     <a:bodyPr/>
                     <a:lstStyle/>
                     <a:p>
-                      <a:pPr algn="l" indent="0" marL="0">
+                      <a:pPr marL="0" indent="0" algn="l">
                         <a:buNone/>
                       </a:pPr>
                       <a:r>
@@ -10004,7 +9786,7 @@
           <a:bodyPr wrap="square" lIns="0" tIns="0" rIns="0" bIns="0" rtlCol="0" anchor="t"/>
           <a:lstStyle/>
           <a:p>
-            <a:pPr indent="0" marL="0">
+            <a:pPr marL="0" indent="0">
               <a:buNone/>
             </a:pPr>
             <a:r>
@@ -10042,7 +9824,7 @@
           </a:prstGeom>
           <a:extLst>
             <a:ext uri="{C572A759-6A51-4108-AA02-DFA0A04FC94B}">
-              <ma14:wrappingTextBoxFlag xmlns:ma14="http://schemas.microsoft.com/office/mac/drawingml/2011/main" val="0"/>
+              <ma14:wrappingTextBoxFlag xmlns:ma14="http://schemas.microsoft.com/office/mac/drawingml/2011/main" xmlns="" val="0"/>
             </a:ext>
           </a:extLst>
         </p:spPr>
@@ -10063,7 +9845,7 @@
           <a:p>
             <a:pPr algn="l"/>
             <a:fld id="{F7021451-1387-4CA6-816F-3879F97B5CBC}" type="slidenum">
-              <a:rPr b="0" lang="en-US"/>
+              <a:rPr lang="en-US" b="0"/>
               <a:t>14</a:t>
             </a:fld>
             <a:endParaRPr lang="en-US"/>
@@ -10116,7 +9898,7 @@
           <a:bodyPr wrap="square" lIns="0" tIns="0" rIns="0" bIns="0" rtlCol="0" anchor="t"/>
           <a:lstStyle/>
           <a:p>
-            <a:pPr indent="0" marL="0">
+            <a:pPr marL="0" indent="0">
               <a:buNone/>
             </a:pPr>
             <a:r>
@@ -10155,7 +9937,7 @@
           <a:bodyPr wrap="square" lIns="0" tIns="0" rIns="0" bIns="0" rtlCol="0" anchor="t"/>
           <a:lstStyle/>
           <a:p>
-            <a:pPr indent="0" marL="0">
+            <a:pPr marL="0" indent="0">
               <a:buNone/>
             </a:pPr>
             <a:r>
@@ -10194,7 +9976,7 @@
           <a:bodyPr wrap="square" lIns="0" tIns="0" rIns="0" bIns="0" rtlCol="0" anchor="t"/>
           <a:lstStyle/>
           <a:p>
-            <a:pPr indent="0" marL="0">
+            <a:pPr marL="0" indent="0">
               <a:buNone/>
             </a:pPr>
             <a:r>
@@ -10240,9 +10022,11 @@
       <p:sp>
         <p:nvSpPr>
           <p:cNvPr id="2" name="Text 0"/>
-          <p:cNvSpPr/>
+          <p:cNvSpPr>
+            <a:spLocks noGrp="1"/>
+          </p:cNvSpPr>
           <p:nvPr>
-            <p:ph idx="100" type="body" hasCustomPrompt="1"/>
+            <p:ph type="body" idx="100" hasCustomPrompt="1"/>
           </p:nvPr>
         </p:nvSpPr>
         <p:spPr>
@@ -10260,11 +10044,11 @@
           <a:bodyPr wrap="square" lIns="0" tIns="0" rIns="0" bIns="0" rtlCol="0"/>
           <a:lstStyle/>
           <a:p>
-            <a:pPr indent="0" marL="0">
+            <a:pPr marL="0" indent="0">
               <a:buNone/>
             </a:pPr>
             <a:r>
-              <a:rPr lang="en-US" sz="1300" spc="200" kern="0" dirty="0">
+              <a:rPr lang="en-US" sz="1300" kern="0" spc="200" dirty="0">
                 <a:solidFill>
                   <a:srgbClr val="B5561C"/>
                 </a:solidFill>
@@ -10281,9 +10065,11 @@
       <p:sp>
         <p:nvSpPr>
           <p:cNvPr id="3" name="Text 0"/>
-          <p:cNvSpPr/>
+          <p:cNvSpPr>
+            <a:spLocks noGrp="1"/>
+          </p:cNvSpPr>
           <p:nvPr>
-            <p:ph idx="101" type="title" hasCustomPrompt="1"/>
+            <p:ph type="title" idx="101" hasCustomPrompt="1"/>
           </p:nvPr>
         </p:nvSpPr>
         <p:spPr>
@@ -10301,7 +10087,7 @@
           <a:bodyPr wrap="square" lIns="0" tIns="0" rIns="0" bIns="0" rtlCol="0" anchor="t"/>
           <a:lstStyle/>
           <a:p>
-            <a:pPr algn="l" indent="0" marL="0">
+            <a:pPr marL="0" indent="0" algn="l">
               <a:buNone/>
             </a:pPr>
             <a:r>
@@ -10367,7 +10153,7 @@
           <a:bodyPr wrap="square" lIns="0" tIns="0" rIns="0" bIns="0" rtlCol="0" anchor="t"/>
           <a:lstStyle/>
           <a:p>
-            <a:pPr indent="0" marL="0">
+            <a:pPr marL="0" indent="0">
               <a:buNone/>
             </a:pPr>
             <a:r>
@@ -10406,7 +10192,7 @@
           <a:bodyPr wrap="square" lIns="0" tIns="0" rIns="0" bIns="0" rtlCol="0" anchor="t"/>
           <a:lstStyle/>
           <a:p>
-            <a:pPr indent="0" marL="0">
+            <a:pPr marL="0" indent="0">
               <a:buNone/>
             </a:pPr>
             <a:r>
@@ -10472,7 +10258,7 @@
           <a:bodyPr wrap="square" lIns="0" tIns="0" rIns="0" bIns="0" rtlCol="0" anchor="t"/>
           <a:lstStyle/>
           <a:p>
-            <a:pPr indent="0" marL="0">
+            <a:pPr marL="0" indent="0">
               <a:buNone/>
             </a:pPr>
             <a:r>
@@ -10511,7 +10297,7 @@
           <a:bodyPr wrap="square" lIns="0" tIns="0" rIns="0" bIns="0" rtlCol="0" anchor="t"/>
           <a:lstStyle/>
           <a:p>
-            <a:pPr indent="0" marL="0">
+            <a:pPr marL="0" indent="0">
               <a:buNone/>
             </a:pPr>
             <a:r>
@@ -10577,7 +10363,7 @@
           <a:bodyPr wrap="square" lIns="0" tIns="0" rIns="0" bIns="0" rtlCol="0" anchor="t"/>
           <a:lstStyle/>
           <a:p>
-            <a:pPr indent="0" marL="0">
+            <a:pPr marL="0" indent="0">
               <a:buNone/>
             </a:pPr>
             <a:r>
@@ -10616,7 +10402,7 @@
           <a:bodyPr wrap="square" lIns="0" tIns="0" rIns="0" bIns="0" rtlCol="0" anchor="t"/>
           <a:lstStyle/>
           <a:p>
-            <a:pPr indent="0" marL="0">
+            <a:pPr marL="0" indent="0">
               <a:buNone/>
             </a:pPr>
             <a:r>
@@ -10654,7 +10440,7 @@
           </a:prstGeom>
           <a:extLst>
             <a:ext uri="{C572A759-6A51-4108-AA02-DFA0A04FC94B}">
-              <ma14:wrappingTextBoxFlag xmlns:ma14="http://schemas.microsoft.com/office/mac/drawingml/2011/main" val="0"/>
+              <ma14:wrappingTextBoxFlag xmlns:ma14="http://schemas.microsoft.com/office/mac/drawingml/2011/main" xmlns="" val="0"/>
             </a:ext>
           </a:extLst>
         </p:spPr>
@@ -10675,7 +10461,7 @@
           <a:p>
             <a:pPr algn="l"/>
             <a:fld id="{F7021451-1387-4CA6-816F-3879F97B5CBC}" type="slidenum">
-              <a:rPr b="0" lang="en-US"/>
+              <a:rPr lang="en-US" b="0"/>
               <a:t>2</a:t>
             </a:fld>
             <a:endParaRPr lang="en-US"/>
@@ -10728,11 +10514,11 @@
           <a:bodyPr wrap="square" lIns="0" tIns="0" rIns="0" bIns="0" rtlCol="0" anchor="t"/>
           <a:lstStyle/>
           <a:p>
-            <a:pPr indent="0" marL="0">
+            <a:pPr marL="0" indent="0">
               <a:buNone/>
             </a:pPr>
             <a:r>
-              <a:rPr lang="en-US" sz="1400" spc="200" kern="0" dirty="0">
+              <a:rPr lang="en-US" sz="1400" kern="0" spc="200" dirty="0">
                 <a:solidFill>
                   <a:srgbClr val="F2A65A"/>
                 </a:solidFill>
@@ -10767,7 +10553,7 @@
           <a:bodyPr wrap="square" lIns="0" tIns="0" rIns="0" bIns="0" rtlCol="0" anchor="t"/>
           <a:lstStyle/>
           <a:p>
-            <a:pPr indent="0" marL="0">
+            <a:pPr marL="0" indent="0">
               <a:buNone/>
             </a:pPr>
             <a:r>
@@ -10806,7 +10592,7 @@
           <a:bodyPr wrap="square" lIns="0" tIns="0" rIns="0" bIns="0" rtlCol="0" anchor="t"/>
           <a:lstStyle/>
           <a:p>
-            <a:pPr indent="0" marL="0">
+            <a:pPr marL="0" indent="0">
               <a:buNone/>
             </a:pPr>
             <a:r>
@@ -10852,9 +10638,11 @@
       <p:sp>
         <p:nvSpPr>
           <p:cNvPr id="2" name="Text 0"/>
-          <p:cNvSpPr/>
+          <p:cNvSpPr>
+            <a:spLocks noGrp="1"/>
+          </p:cNvSpPr>
           <p:nvPr>
-            <p:ph idx="100" type="body" hasCustomPrompt="1"/>
+            <p:ph type="body" idx="100" hasCustomPrompt="1"/>
           </p:nvPr>
         </p:nvSpPr>
         <p:spPr>
@@ -10872,11 +10660,11 @@
           <a:bodyPr wrap="square" lIns="0" tIns="0" rIns="0" bIns="0" rtlCol="0"/>
           <a:lstStyle/>
           <a:p>
-            <a:pPr indent="0" marL="0">
+            <a:pPr marL="0" indent="0">
               <a:buNone/>
             </a:pPr>
             <a:r>
-              <a:rPr lang="en-US" sz="1300" spc="200" kern="0" dirty="0">
+              <a:rPr lang="en-US" sz="1300" kern="0" spc="200" dirty="0">
                 <a:solidFill>
                   <a:srgbClr val="B5561C"/>
                 </a:solidFill>
@@ -10893,9 +10681,11 @@
       <p:sp>
         <p:nvSpPr>
           <p:cNvPr id="3" name="Text 0"/>
-          <p:cNvSpPr/>
+          <p:cNvSpPr>
+            <a:spLocks noGrp="1"/>
+          </p:cNvSpPr>
           <p:nvPr>
-            <p:ph idx="101" type="title" hasCustomPrompt="1"/>
+            <p:ph type="title" idx="101" hasCustomPrompt="1"/>
           </p:nvPr>
         </p:nvSpPr>
         <p:spPr>
@@ -10913,7 +10703,7 @@
           <a:bodyPr wrap="square" lIns="0" tIns="0" rIns="0" bIns="0" rtlCol="0" anchor="t"/>
           <a:lstStyle/>
           <a:p>
-            <a:pPr algn="l" indent="0" marL="0">
+            <a:pPr marL="0" indent="0" algn="l">
               <a:buNone/>
             </a:pPr>
             <a:r>
@@ -10979,7 +10769,7 @@
           <a:bodyPr wrap="square" lIns="0" tIns="0" rIns="0" bIns="0" rtlCol="0" anchor="t"/>
           <a:lstStyle/>
           <a:p>
-            <a:pPr indent="0" marL="0">
+            <a:pPr marL="0" indent="0">
               <a:buNone/>
             </a:pPr>
             <a:r>
@@ -11018,7 +10808,7 @@
           <a:bodyPr wrap="square" lIns="0" tIns="0" rIns="0" bIns="0" rtlCol="0" anchor="t"/>
           <a:lstStyle/>
           <a:p>
-            <a:pPr indent="0" marL="0">
+            <a:pPr marL="0" indent="0">
               <a:buNone/>
             </a:pPr>
             <a:r>
@@ -11057,7 +10847,7 @@
           <a:bodyPr wrap="square" lIns="0" tIns="0" rIns="0" bIns="0" rtlCol="0" anchor="t"/>
           <a:lstStyle/>
           <a:p>
-            <a:pPr indent="0" marL="0">
+            <a:pPr marL="0" indent="0">
               <a:buNone/>
             </a:pPr>
             <a:r>
@@ -11148,7 +10938,7 @@
           <a:bodyPr wrap="square" lIns="0" tIns="0" rIns="0" bIns="0" rtlCol="0" anchor="t"/>
           <a:lstStyle/>
           <a:p>
-            <a:pPr indent="0" marL="0">
+            <a:pPr marL="0" indent="0">
               <a:buNone/>
             </a:pPr>
             <a:r>
@@ -11187,7 +10977,7 @@
           <a:bodyPr wrap="square" lIns="0" tIns="0" rIns="0" bIns="0" rtlCol="0" anchor="t"/>
           <a:lstStyle/>
           <a:p>
-            <a:pPr indent="0" marL="0">
+            <a:pPr marL="0" indent="0">
               <a:buNone/>
             </a:pPr>
             <a:r>
@@ -11226,7 +11016,7 @@
           <a:bodyPr wrap="square" lIns="0" tIns="0" rIns="0" bIns="0" rtlCol="0" anchor="t"/>
           <a:lstStyle/>
           <a:p>
-            <a:pPr indent="0" marL="0">
+            <a:pPr marL="0" indent="0">
               <a:buNone/>
             </a:pPr>
             <a:r>
@@ -11317,7 +11107,7 @@
           <a:bodyPr wrap="square" lIns="0" tIns="0" rIns="0" bIns="0" rtlCol="0" anchor="t"/>
           <a:lstStyle/>
           <a:p>
-            <a:pPr indent="0" marL="0">
+            <a:pPr marL="0" indent="0">
               <a:buNone/>
             </a:pPr>
             <a:r>
@@ -11356,7 +11146,7 @@
           <a:bodyPr wrap="square" lIns="0" tIns="0" rIns="0" bIns="0" rtlCol="0" anchor="t"/>
           <a:lstStyle/>
           <a:p>
-            <a:pPr indent="0" marL="0">
+            <a:pPr marL="0" indent="0">
               <a:buNone/>
             </a:pPr>
             <a:r>
@@ -11395,7 +11185,7 @@
           <a:bodyPr wrap="square" lIns="0" tIns="0" rIns="0" bIns="0" rtlCol="0" anchor="t"/>
           <a:lstStyle/>
           <a:p>
-            <a:pPr indent="0" marL="0">
+            <a:pPr marL="0" indent="0">
               <a:buNone/>
             </a:pPr>
             <a:r>
@@ -11486,7 +11276,7 @@
           <a:bodyPr wrap="square" lIns="0" tIns="0" rIns="0" bIns="0" rtlCol="0" anchor="t"/>
           <a:lstStyle/>
           <a:p>
-            <a:pPr indent="0" marL="0">
+            <a:pPr marL="0" indent="0">
               <a:buNone/>
             </a:pPr>
             <a:r>
@@ -11525,7 +11315,7 @@
           <a:bodyPr wrap="square" lIns="0" tIns="0" rIns="0" bIns="0" rtlCol="0" anchor="t"/>
           <a:lstStyle/>
           <a:p>
-            <a:pPr indent="0" marL="0">
+            <a:pPr marL="0" indent="0">
               <a:buNone/>
             </a:pPr>
             <a:r>
@@ -11564,7 +11354,7 @@
           <a:bodyPr wrap="square" lIns="0" tIns="0" rIns="0" bIns="0" rtlCol="0" anchor="t"/>
           <a:lstStyle/>
           <a:p>
-            <a:pPr indent="0" marL="0">
+            <a:pPr marL="0" indent="0">
               <a:buNone/>
             </a:pPr>
             <a:r>
@@ -11655,7 +11445,7 @@
           <a:bodyPr wrap="square" lIns="0" tIns="0" rIns="0" bIns="0" rtlCol="0" anchor="t"/>
           <a:lstStyle/>
           <a:p>
-            <a:pPr indent="0" marL="0">
+            <a:pPr marL="0" indent="0">
               <a:buNone/>
             </a:pPr>
             <a:r>
@@ -11694,7 +11484,7 @@
           <a:bodyPr wrap="square" lIns="0" tIns="0" rIns="0" bIns="0" rtlCol="0" anchor="t"/>
           <a:lstStyle/>
           <a:p>
-            <a:pPr indent="0" marL="0">
+            <a:pPr marL="0" indent="0">
               <a:buNone/>
             </a:pPr>
             <a:r>
@@ -11733,7 +11523,7 @@
           <a:bodyPr wrap="square" lIns="0" tIns="0" rIns="0" bIns="0" rtlCol="0" anchor="t"/>
           <a:lstStyle/>
           <a:p>
-            <a:pPr indent="0" marL="0">
+            <a:pPr marL="0" indent="0">
               <a:buNone/>
             </a:pPr>
             <a:r>
@@ -11772,7 +11562,7 @@
           <a:bodyPr wrap="square" lIns="0" tIns="0" rIns="0" bIns="0" rtlCol="0" anchor="t"/>
           <a:lstStyle/>
           <a:p>
-            <a:pPr indent="0" marL="0">
+            <a:pPr marL="0" indent="0">
               <a:buNone/>
             </a:pPr>
             <a:r>
@@ -11792,7 +11582,7 @@
       </p:sp>
       <p:sp>
         <p:nvSpPr>
-          <p:cNvPr id="25" name="Slide Number Placeholder 0"/>
+          <p:cNvPr id="29" name="Slide Number Placeholder 0"/>
           <p:cNvSpPr>
             <a:spLocks noGrp="1"/>
           </p:cNvSpPr>
@@ -11810,7 +11600,7 @@
           </a:prstGeom>
           <a:extLst>
             <a:ext uri="{C572A759-6A51-4108-AA02-DFA0A04FC94B}">
-              <ma14:wrappingTextBoxFlag xmlns:ma14="http://schemas.microsoft.com/office/mac/drawingml/2011/main" val="0"/>
+              <ma14:wrappingTextBoxFlag xmlns:ma14="http://schemas.microsoft.com/office/mac/drawingml/2011/main" xmlns="" val="0"/>
             </a:ext>
           </a:extLst>
         </p:spPr>
@@ -11831,7 +11621,7 @@
           <a:p>
             <a:pPr algn="l"/>
             <a:fld id="{F7021451-1387-4CA6-816F-3879F97B5CBC}" type="slidenum">
-              <a:rPr b="0" lang="en-US"/>
+              <a:rPr lang="en-US" b="0"/>
               <a:t>4</a:t>
             </a:fld>
             <a:endParaRPr lang="en-US"/>
@@ -11866,9 +11656,11 @@
       <p:sp>
         <p:nvSpPr>
           <p:cNvPr id="2" name="Text 0"/>
-          <p:cNvSpPr/>
+          <p:cNvSpPr>
+            <a:spLocks noGrp="1"/>
+          </p:cNvSpPr>
           <p:nvPr>
-            <p:ph idx="100" type="body" hasCustomPrompt="1"/>
+            <p:ph type="body" idx="100" hasCustomPrompt="1"/>
           </p:nvPr>
         </p:nvSpPr>
         <p:spPr>
@@ -11886,11 +11678,11 @@
           <a:bodyPr wrap="square" lIns="0" tIns="0" rIns="0" bIns="0" rtlCol="0"/>
           <a:lstStyle/>
           <a:p>
-            <a:pPr indent="0" marL="0">
+            <a:pPr marL="0" indent="0">
               <a:buNone/>
             </a:pPr>
             <a:r>
-              <a:rPr lang="en-US" sz="1300" spc="200" kern="0" dirty="0">
+              <a:rPr lang="en-US" sz="1300" kern="0" spc="200" dirty="0">
                 <a:solidFill>
                   <a:srgbClr val="B5561C"/>
                 </a:solidFill>
@@ -11907,9 +11699,11 @@
       <p:sp>
         <p:nvSpPr>
           <p:cNvPr id="3" name="Text 0"/>
-          <p:cNvSpPr/>
+          <p:cNvSpPr>
+            <a:spLocks noGrp="1"/>
+          </p:cNvSpPr>
           <p:nvPr>
-            <p:ph idx="101" type="title" hasCustomPrompt="1"/>
+            <p:ph type="title" idx="101" hasCustomPrompt="1"/>
           </p:nvPr>
         </p:nvSpPr>
         <p:spPr>
@@ -11927,7 +11721,7 @@
           <a:bodyPr wrap="square" lIns="0" tIns="0" rIns="0" bIns="0" rtlCol="0" anchor="t"/>
           <a:lstStyle/>
           <a:p>
-            <a:pPr algn="l" indent="0" marL="0">
+            <a:pPr marL="0" indent="0" algn="l">
               <a:buNone/>
             </a:pPr>
             <a:r>
@@ -11993,7 +11787,7 @@
           <a:bodyPr wrap="square" lIns="0" tIns="0" rIns="0" bIns="0" rtlCol="0" anchor="t"/>
           <a:lstStyle/>
           <a:p>
-            <a:pPr indent="0" marL="0">
+            <a:pPr marL="0" indent="0">
               <a:buNone/>
             </a:pPr>
             <a:r>
@@ -12032,7 +11826,7 @@
           <a:bodyPr wrap="square" lIns="0" tIns="0" rIns="0" bIns="0" rtlCol="0" anchor="t"/>
           <a:lstStyle/>
           <a:p>
-            <a:pPr indent="0" marL="0">
+            <a:pPr marL="0" indent="0">
               <a:buNone/>
             </a:pPr>
             <a:r>
@@ -12071,7 +11865,7 @@
           <a:bodyPr wrap="square" lIns="0" tIns="0" rIns="0" bIns="0" rtlCol="0" anchor="t"/>
           <a:lstStyle/>
           <a:p>
-            <a:pPr indent="0" marL="0">
+            <a:pPr marL="0" indent="0">
               <a:buNone/>
             </a:pPr>
             <a:r>
@@ -12137,7 +11931,7 @@
           <a:bodyPr wrap="square" lIns="0" tIns="0" rIns="0" bIns="0" rtlCol="0" anchor="t"/>
           <a:lstStyle/>
           <a:p>
-            <a:pPr indent="0" marL="0">
+            <a:pPr marL="0" indent="0">
               <a:buNone/>
             </a:pPr>
             <a:r>
@@ -12176,7 +11970,7 @@
           <a:bodyPr wrap="square" lIns="0" tIns="0" rIns="0" bIns="0" rtlCol="0" anchor="t"/>
           <a:lstStyle/>
           <a:p>
-            <a:pPr indent="0" marL="0">
+            <a:pPr marL="0" indent="0">
               <a:buNone/>
             </a:pPr>
             <a:r>
@@ -12215,7 +12009,7 @@
           <a:bodyPr wrap="square" lIns="0" tIns="0" rIns="0" bIns="0" rtlCol="0" anchor="t"/>
           <a:lstStyle/>
           <a:p>
-            <a:pPr indent="0" marL="0">
+            <a:pPr marL="0" indent="0">
               <a:buNone/>
             </a:pPr>
             <a:r>
@@ -12281,7 +12075,7 @@
           <a:bodyPr wrap="square" lIns="0" tIns="0" rIns="0" bIns="0" rtlCol="0" anchor="t"/>
           <a:lstStyle/>
           <a:p>
-            <a:pPr indent="0" marL="0">
+            <a:pPr marL="0" indent="0">
               <a:buNone/>
             </a:pPr>
             <a:r>
@@ -12320,7 +12114,7 @@
           <a:bodyPr wrap="square" lIns="0" tIns="0" rIns="0" bIns="0" rtlCol="0" anchor="t"/>
           <a:lstStyle/>
           <a:p>
-            <a:pPr indent="0" marL="0">
+            <a:pPr marL="0" indent="0">
               <a:buNone/>
             </a:pPr>
             <a:r>
@@ -12359,7 +12153,7 @@
           <a:bodyPr wrap="square" lIns="0" tIns="0" rIns="0" bIns="0" rtlCol="0" anchor="t"/>
           <a:lstStyle/>
           <a:p>
-            <a:pPr indent="0" marL="0">
+            <a:pPr marL="0" indent="0">
               <a:buNone/>
             </a:pPr>
             <a:r>
@@ -12398,7 +12192,7 @@
           <a:bodyPr wrap="square" lIns="0" tIns="0" rIns="0" bIns="0" rtlCol="0" anchor="t"/>
           <a:lstStyle/>
           <a:p>
-            <a:pPr indent="0" marL="0">
+            <a:pPr marL="0" indent="0">
               <a:buNone/>
             </a:pPr>
             <a:r>
@@ -12436,7 +12230,7 @@
           </a:prstGeom>
           <a:extLst>
             <a:ext uri="{C572A759-6A51-4108-AA02-DFA0A04FC94B}">
-              <ma14:wrappingTextBoxFlag xmlns:ma14="http://schemas.microsoft.com/office/mac/drawingml/2011/main" val="0"/>
+              <ma14:wrappingTextBoxFlag xmlns:ma14="http://schemas.microsoft.com/office/mac/drawingml/2011/main" xmlns="" val="0"/>
             </a:ext>
           </a:extLst>
         </p:spPr>
@@ -12457,7 +12251,7 @@
           <a:p>
             <a:pPr algn="l"/>
             <a:fld id="{F7021451-1387-4CA6-816F-3879F97B5CBC}" type="slidenum">
-              <a:rPr b="0" lang="en-US"/>
+              <a:rPr lang="en-US" b="0"/>
               <a:t>5</a:t>
             </a:fld>
             <a:endParaRPr lang="en-US"/>
@@ -12492,9 +12286,11 @@
       <p:sp>
         <p:nvSpPr>
           <p:cNvPr id="2" name="Text 0"/>
-          <p:cNvSpPr/>
+          <p:cNvSpPr>
+            <a:spLocks noGrp="1"/>
+          </p:cNvSpPr>
           <p:nvPr>
-            <p:ph idx="100" type="body" hasCustomPrompt="1"/>
+            <p:ph type="body" idx="100" hasCustomPrompt="1"/>
           </p:nvPr>
         </p:nvSpPr>
         <p:spPr>
@@ -12512,11 +12308,11 @@
           <a:bodyPr wrap="square" lIns="0" tIns="0" rIns="0" bIns="0" rtlCol="0"/>
           <a:lstStyle/>
           <a:p>
-            <a:pPr indent="0" marL="0">
+            <a:pPr marL="0" indent="0">
               <a:buNone/>
             </a:pPr>
             <a:r>
-              <a:rPr lang="en-US" sz="1300" spc="200" kern="0" dirty="0">
+              <a:rPr lang="en-US" sz="1300" kern="0" spc="200" dirty="0">
                 <a:solidFill>
                   <a:srgbClr val="B5561C"/>
                 </a:solidFill>
@@ -12533,9 +12329,11 @@
       <p:sp>
         <p:nvSpPr>
           <p:cNvPr id="3" name="Text 0"/>
-          <p:cNvSpPr/>
+          <p:cNvSpPr>
+            <a:spLocks noGrp="1"/>
+          </p:cNvSpPr>
           <p:nvPr>
-            <p:ph idx="101" type="title" hasCustomPrompt="1"/>
+            <p:ph type="title" idx="101" hasCustomPrompt="1"/>
           </p:nvPr>
         </p:nvSpPr>
         <p:spPr>
@@ -12553,7 +12351,7 @@
           <a:bodyPr wrap="square" lIns="0" tIns="0" rIns="0" bIns="0" rtlCol="0" anchor="t"/>
           <a:lstStyle/>
           <a:p>
-            <a:pPr algn="l" indent="0" marL="0">
+            <a:pPr marL="0" indent="0" algn="l">
               <a:buNone/>
             </a:pPr>
             <a:r>
@@ -12587,7 +12385,7 @@
         </p:nvGraphicFramePr>
         <p:xfrm>
           <a:off x="548640" y="1828800"/>
-          <a:ext cx="11064240" cy="914400"/>
+          <a:ext cx="11064240" cy="2514600"/>
         </p:xfrm>
         <a:graphic>
           <a:graphicData uri="http://schemas.openxmlformats.org/drawingml/2006/table">
@@ -12604,7 +12402,7 @@
                     <a:bodyPr/>
                     <a:lstStyle/>
                     <a:p>
-                      <a:pPr algn="l" indent="0" marL="0">
+                      <a:pPr marL="0" indent="0" algn="l">
                         <a:buNone/>
                       </a:pPr>
                       <a:r>
@@ -12672,7 +12470,7 @@
                     <a:bodyPr/>
                     <a:lstStyle/>
                     <a:p>
-                      <a:pPr algn="l" indent="0" marL="0">
+                      <a:pPr marL="0" indent="0" algn="l">
                         <a:buNone/>
                       </a:pPr>
                       <a:r>
@@ -12740,7 +12538,7 @@
                     <a:bodyPr/>
                     <a:lstStyle/>
                     <a:p>
-                      <a:pPr algn="l" indent="0" marL="0">
+                      <a:pPr marL="0" indent="0" algn="l">
                         <a:buNone/>
                       </a:pPr>
                       <a:r>
@@ -12810,7 +12608,7 @@
                     <a:bodyPr/>
                     <a:lstStyle/>
                     <a:p>
-                      <a:pPr algn="l" indent="0" marL="0">
+                      <a:pPr marL="0" indent="0" algn="l">
                         <a:buNone/>
                       </a:pPr>
                       <a:r>
@@ -12878,7 +12676,7 @@
                     <a:bodyPr/>
                     <a:lstStyle/>
                     <a:p>
-                      <a:pPr algn="l" indent="0" marL="0">
+                      <a:pPr marL="0" indent="0" algn="l">
                         <a:buNone/>
                       </a:pPr>
                       <a:r>
@@ -12946,7 +12744,7 @@
                     <a:bodyPr/>
                     <a:lstStyle/>
                     <a:p>
-                      <a:pPr algn="l" indent="0" marL="0">
+                      <a:pPr marL="0" indent="0" algn="l">
                         <a:buNone/>
                       </a:pPr>
                       <a:r>
@@ -13016,7 +12814,7 @@
                     <a:bodyPr/>
                     <a:lstStyle/>
                     <a:p>
-                      <a:pPr algn="l" indent="0" marL="0">
+                      <a:pPr marL="0" indent="0" algn="l">
                         <a:buNone/>
                       </a:pPr>
                       <a:r>
@@ -13084,7 +12882,7 @@
                     <a:bodyPr/>
                     <a:lstStyle/>
                     <a:p>
-                      <a:pPr algn="l" indent="0" marL="0">
+                      <a:pPr marL="0" indent="0" algn="l">
                         <a:buNone/>
                       </a:pPr>
                       <a:r>
@@ -13152,7 +12950,7 @@
                     <a:bodyPr/>
                     <a:lstStyle/>
                     <a:p>
-                      <a:pPr algn="l" indent="0" marL="0">
+                      <a:pPr marL="0" indent="0" algn="l">
                         <a:buNone/>
                       </a:pPr>
                       <a:r>
@@ -13222,7 +13020,7 @@
                     <a:bodyPr/>
                     <a:lstStyle/>
                     <a:p>
-                      <a:pPr algn="l" indent="0" marL="0">
+                      <a:pPr marL="0" indent="0" algn="l">
                         <a:buNone/>
                       </a:pPr>
                       <a:r>
@@ -13290,7 +13088,7 @@
                     <a:bodyPr/>
                     <a:lstStyle/>
                     <a:p>
-                      <a:pPr algn="l" indent="0" marL="0">
+                      <a:pPr marL="0" indent="0" algn="l">
                         <a:buNone/>
                       </a:pPr>
                       <a:r>
@@ -13358,7 +13156,7 @@
                     <a:bodyPr/>
                     <a:lstStyle/>
                     <a:p>
-                      <a:pPr algn="l" indent="0" marL="0">
+                      <a:pPr marL="0" indent="0" algn="l">
                         <a:buNone/>
                       </a:pPr>
                       <a:r>
@@ -13428,7 +13226,7 @@
                     <a:bodyPr/>
                     <a:lstStyle/>
                     <a:p>
-                      <a:pPr algn="l" indent="0" marL="0">
+                      <a:pPr marL="0" indent="0" algn="l">
                         <a:buNone/>
                       </a:pPr>
                       <a:r>
@@ -13496,7 +13294,7 @@
                     <a:bodyPr/>
                     <a:lstStyle/>
                     <a:p>
-                      <a:pPr algn="l" indent="0" marL="0">
+                      <a:pPr marL="0" indent="0" algn="l">
                         <a:buNone/>
                       </a:pPr>
                       <a:r>
@@ -13564,7 +13362,7 @@
                     <a:bodyPr/>
                     <a:lstStyle/>
                     <a:p>
-                      <a:pPr algn="l" indent="0" marL="0">
+                      <a:pPr marL="0" indent="0" algn="l">
                         <a:buNone/>
                       </a:pPr>
                       <a:r>
@@ -13653,7 +13451,7 @@
           <a:bodyPr wrap="square" lIns="0" tIns="0" rIns="0" bIns="0" rtlCol="0" anchor="t"/>
           <a:lstStyle/>
           <a:p>
-            <a:pPr indent="0" marL="0">
+            <a:pPr marL="0" indent="0">
               <a:buNone/>
             </a:pPr>
             <a:r>
@@ -13691,7 +13489,7 @@
           </a:prstGeom>
           <a:extLst>
             <a:ext uri="{C572A759-6A51-4108-AA02-DFA0A04FC94B}">
-              <ma14:wrappingTextBoxFlag xmlns:ma14="http://schemas.microsoft.com/office/mac/drawingml/2011/main" val="0"/>
+              <ma14:wrappingTextBoxFlag xmlns:ma14="http://schemas.microsoft.com/office/mac/drawingml/2011/main" xmlns="" val="0"/>
             </a:ext>
           </a:extLst>
         </p:spPr>
@@ -13712,7 +13510,7 @@
           <a:p>
             <a:pPr algn="l"/>
             <a:fld id="{F7021451-1387-4CA6-816F-3879F97B5CBC}" type="slidenum">
-              <a:rPr b="0" lang="en-US"/>
+              <a:rPr lang="en-US" b="0"/>
               <a:t>6</a:t>
             </a:fld>
             <a:endParaRPr lang="en-US"/>
@@ -13747,9 +13545,11 @@
       <p:sp>
         <p:nvSpPr>
           <p:cNvPr id="2" name="Text 0"/>
-          <p:cNvSpPr/>
+          <p:cNvSpPr>
+            <a:spLocks noGrp="1"/>
+          </p:cNvSpPr>
           <p:nvPr>
-            <p:ph idx="100" type="body" hasCustomPrompt="1"/>
+            <p:ph type="body" idx="100" hasCustomPrompt="1"/>
           </p:nvPr>
         </p:nvSpPr>
         <p:spPr>
@@ -13767,11 +13567,11 @@
           <a:bodyPr wrap="square" lIns="0" tIns="0" rIns="0" bIns="0" rtlCol="0"/>
           <a:lstStyle/>
           <a:p>
-            <a:pPr indent="0" marL="0">
+            <a:pPr marL="0" indent="0">
               <a:buNone/>
             </a:pPr>
             <a:r>
-              <a:rPr lang="en-US" sz="1300" spc="200" kern="0" dirty="0">
+              <a:rPr lang="en-US" sz="1300" kern="0" spc="200" dirty="0">
                 <a:solidFill>
                   <a:srgbClr val="B5561C"/>
                 </a:solidFill>
@@ -13788,9 +13588,11 @@
       <p:sp>
         <p:nvSpPr>
           <p:cNvPr id="3" name="Text 0"/>
-          <p:cNvSpPr/>
+          <p:cNvSpPr>
+            <a:spLocks noGrp="1"/>
+          </p:cNvSpPr>
           <p:nvPr>
-            <p:ph idx="101" type="title" hasCustomPrompt="1"/>
+            <p:ph type="title" idx="101" hasCustomPrompt="1"/>
           </p:nvPr>
         </p:nvSpPr>
         <p:spPr>
@@ -13808,7 +13610,7 @@
           <a:bodyPr wrap="square" lIns="0" tIns="0" rIns="0" bIns="0" rtlCol="0" anchor="t"/>
           <a:lstStyle/>
           <a:p>
-            <a:pPr algn="l" indent="0" marL="0">
+            <a:pPr marL="0" indent="0" algn="l">
               <a:buNone/>
             </a:pPr>
             <a:r>
@@ -13842,7 +13644,7 @@
         </p:nvGraphicFramePr>
         <p:xfrm>
           <a:off x="548640" y="1783080"/>
-          <a:ext cx="11064240" cy="914400"/>
+          <a:ext cx="11064240" cy="3200400"/>
         </p:xfrm>
         <a:graphic>
           <a:graphicData uri="http://schemas.openxmlformats.org/drawingml/2006/table">
@@ -13861,7 +13663,7 @@
                     <a:bodyPr/>
                     <a:lstStyle/>
                     <a:p>
-                      <a:pPr algn="l" indent="0" marL="0">
+                      <a:pPr marL="0" indent="0" algn="l">
                         <a:buNone/>
                       </a:pPr>
                       <a:r>
@@ -13929,7 +13731,7 @@
                     <a:bodyPr/>
                     <a:lstStyle/>
                     <a:p>
-                      <a:pPr algn="r" indent="0" marL="0">
+                      <a:pPr marL="0" indent="0" algn="r">
                         <a:buNone/>
                       </a:pPr>
                       <a:r>
@@ -13997,7 +13799,7 @@
                     <a:bodyPr/>
                     <a:lstStyle/>
                     <a:p>
-                      <a:pPr algn="r" indent="0" marL="0">
+                      <a:pPr marL="0" indent="0" algn="r">
                         <a:buNone/>
                       </a:pPr>
                       <a:r>
@@ -14065,7 +13867,7 @@
                     <a:bodyPr/>
                     <a:lstStyle/>
                     <a:p>
-                      <a:pPr algn="r" indent="0" marL="0">
+                      <a:pPr marL="0" indent="0" algn="r">
                         <a:buNone/>
                       </a:pPr>
                       <a:r>
@@ -14133,7 +13935,7 @@
                     <a:bodyPr/>
                     <a:lstStyle/>
                     <a:p>
-                      <a:pPr algn="r" indent="0" marL="0">
+                      <a:pPr marL="0" indent="0" algn="r">
                         <a:buNone/>
                       </a:pPr>
                       <a:r>
@@ -14203,7 +14005,7 @@
                     <a:bodyPr/>
                     <a:lstStyle/>
                     <a:p>
-                      <a:pPr algn="l" indent="0" marL="0">
+                      <a:pPr marL="0" indent="0" algn="l">
                         <a:buNone/>
                       </a:pPr>
                       <a:r>
@@ -14271,7 +14073,7 @@
                     <a:bodyPr/>
                     <a:lstStyle/>
                     <a:p>
-                      <a:pPr algn="r" indent="0" marL="0">
+                      <a:pPr marL="0" indent="0" algn="r">
                         <a:buNone/>
                       </a:pPr>
                       <a:r>
@@ -14339,7 +14141,7 @@
                     <a:bodyPr/>
                     <a:lstStyle/>
                     <a:p>
-                      <a:pPr algn="r" indent="0" marL="0">
+                      <a:pPr marL="0" indent="0" algn="r">
                         <a:buNone/>
                       </a:pPr>
                       <a:r>
@@ -14407,7 +14209,7 @@
                     <a:bodyPr/>
                     <a:lstStyle/>
                     <a:p>
-                      <a:pPr algn="r" indent="0" marL="0">
+                      <a:pPr marL="0" indent="0" algn="r">
                         <a:buNone/>
                       </a:pPr>
                       <a:r>
@@ -14475,7 +14277,7 @@
                     <a:bodyPr/>
                     <a:lstStyle/>
                     <a:p>
-                      <a:pPr algn="r" indent="0" marL="0">
+                      <a:pPr marL="0" indent="0" algn="r">
                         <a:buNone/>
                       </a:pPr>
                       <a:r>
@@ -14545,7 +14347,7 @@
                     <a:bodyPr/>
                     <a:lstStyle/>
                     <a:p>
-                      <a:pPr algn="l" indent="0" marL="0">
+                      <a:pPr marL="0" indent="0" algn="l">
                         <a:buNone/>
                       </a:pPr>
                       <a:r>
@@ -14613,7 +14415,7 @@
                     <a:bodyPr/>
                     <a:lstStyle/>
                     <a:p>
-                      <a:pPr algn="r" indent="0" marL="0">
+                      <a:pPr marL="0" indent="0" algn="r">
                         <a:buNone/>
                       </a:pPr>
                       <a:r>
@@ -14681,7 +14483,7 @@
                     <a:bodyPr/>
                     <a:lstStyle/>
                     <a:p>
-                      <a:pPr algn="r" indent="0" marL="0">
+                      <a:pPr marL="0" indent="0" algn="r">
                         <a:buNone/>
                       </a:pPr>
                       <a:r>
@@ -14749,7 +14551,7 @@
                     <a:bodyPr/>
                     <a:lstStyle/>
                     <a:p>
-                      <a:pPr algn="r" indent="0" marL="0">
+                      <a:pPr marL="0" indent="0" algn="r">
                         <a:buNone/>
                       </a:pPr>
                       <a:r>
@@ -14817,7 +14619,7 @@
                     <a:bodyPr/>
                     <a:lstStyle/>
                     <a:p>
-                      <a:pPr algn="r" indent="0" marL="0">
+                      <a:pPr marL="0" indent="0" algn="r">
                         <a:buNone/>
                       </a:pPr>
                       <a:r>
@@ -14887,7 +14689,7 @@
                     <a:bodyPr/>
                     <a:lstStyle/>
                     <a:p>
-                      <a:pPr algn="l" indent="0" marL="0">
+                      <a:pPr marL="0" indent="0" algn="l">
                         <a:buNone/>
                       </a:pPr>
                       <a:r>
@@ -14955,7 +14757,7 @@
                     <a:bodyPr/>
                     <a:lstStyle/>
                     <a:p>
-                      <a:pPr algn="r" indent="0" marL="0">
+                      <a:pPr marL="0" indent="0" algn="r">
                         <a:buNone/>
                       </a:pPr>
                       <a:r>
@@ -15023,7 +14825,7 @@
                     <a:bodyPr/>
                     <a:lstStyle/>
                     <a:p>
-                      <a:pPr algn="r" indent="0" marL="0">
+                      <a:pPr marL="0" indent="0" algn="r">
                         <a:buNone/>
                       </a:pPr>
                       <a:r>
@@ -15091,7 +14893,7 @@
                     <a:bodyPr/>
                     <a:lstStyle/>
                     <a:p>
-                      <a:pPr algn="r" indent="0" marL="0">
+                      <a:pPr marL="0" indent="0" algn="r">
                         <a:buNone/>
                       </a:pPr>
                       <a:r>
@@ -15159,7 +14961,7 @@
                     <a:bodyPr/>
                     <a:lstStyle/>
                     <a:p>
-                      <a:pPr algn="r" indent="0" marL="0">
+                      <a:pPr marL="0" indent="0" algn="r">
                         <a:buNone/>
                       </a:pPr>
                       <a:r>
@@ -15229,7 +15031,7 @@
                     <a:bodyPr/>
                     <a:lstStyle/>
                     <a:p>
-                      <a:pPr algn="l" indent="0" marL="0">
+                      <a:pPr marL="0" indent="0" algn="l">
                         <a:buNone/>
                       </a:pPr>
                       <a:r>
@@ -15297,7 +15099,7 @@
                     <a:bodyPr/>
                     <a:lstStyle/>
                     <a:p>
-                      <a:pPr algn="r" indent="0" marL="0">
+                      <a:pPr marL="0" indent="0" algn="r">
                         <a:buNone/>
                       </a:pPr>
                       <a:r>
@@ -15365,7 +15167,7 @@
                     <a:bodyPr/>
                     <a:lstStyle/>
                     <a:p>
-                      <a:pPr algn="r" indent="0" marL="0">
+                      <a:pPr marL="0" indent="0" algn="r">
                         <a:buNone/>
                       </a:pPr>
                       <a:r>
@@ -15433,7 +15235,7 @@
                     <a:bodyPr/>
                     <a:lstStyle/>
                     <a:p>
-                      <a:pPr algn="r" indent="0" marL="0">
+                      <a:pPr marL="0" indent="0" algn="r">
                         <a:buNone/>
                       </a:pPr>
                       <a:r>
@@ -15501,7 +15303,7 @@
                     <a:bodyPr/>
                     <a:lstStyle/>
                     <a:p>
-                      <a:pPr algn="r" indent="0" marL="0">
+                      <a:pPr marL="0" indent="0" algn="r">
                         <a:buNone/>
                       </a:pPr>
                       <a:r>
@@ -15571,7 +15373,7 @@
                     <a:bodyPr/>
                     <a:lstStyle/>
                     <a:p>
-                      <a:pPr algn="l" indent="0" marL="0">
+                      <a:pPr marL="0" indent="0" algn="l">
                         <a:buNone/>
                       </a:pPr>
                       <a:r>
@@ -15639,7 +15441,7 @@
                     <a:bodyPr/>
                     <a:lstStyle/>
                     <a:p>
-                      <a:pPr algn="r" indent="0" marL="0">
+                      <a:pPr marL="0" indent="0" algn="r">
                         <a:buNone/>
                       </a:pPr>
                       <a:r>
@@ -15707,7 +15509,7 @@
                     <a:bodyPr/>
                     <a:lstStyle/>
                     <a:p>
-                      <a:pPr algn="r" indent="0" marL="0">
+                      <a:pPr marL="0" indent="0" algn="r">
                         <a:buNone/>
                       </a:pPr>
                       <a:r>
@@ -15775,7 +15577,7 @@
                     <a:bodyPr/>
                     <a:lstStyle/>
                     <a:p>
-                      <a:pPr algn="r" indent="0" marL="0">
+                      <a:pPr marL="0" indent="0" algn="r">
                         <a:buNone/>
                       </a:pPr>
                       <a:r>
@@ -15843,7 +15645,7 @@
                     <a:bodyPr/>
                     <a:lstStyle/>
                     <a:p>
-                      <a:pPr algn="r" indent="0" marL="0">
+                      <a:pPr marL="0" indent="0" algn="r">
                         <a:buNone/>
                       </a:pPr>
                       <a:r>
@@ -15913,7 +15715,7 @@
                     <a:bodyPr/>
                     <a:lstStyle/>
                     <a:p>
-                      <a:pPr algn="l" indent="0" marL="0">
+                      <a:pPr marL="0" indent="0" algn="l">
                         <a:buNone/>
                       </a:pPr>
                       <a:r>
@@ -15981,7 +15783,7 @@
                     <a:bodyPr/>
                     <a:lstStyle/>
                     <a:p>
-                      <a:pPr algn="r" indent="0" marL="0">
+                      <a:pPr marL="0" indent="0" algn="r">
                         <a:buNone/>
                       </a:pPr>
                       <a:r>
@@ -16049,7 +15851,7 @@
                     <a:bodyPr/>
                     <a:lstStyle/>
                     <a:p>
-                      <a:pPr algn="r" indent="0" marL="0">
+                      <a:pPr marL="0" indent="0" algn="r">
                         <a:buNone/>
                       </a:pPr>
                       <a:r>
@@ -16117,7 +15919,7 @@
                     <a:bodyPr/>
                     <a:lstStyle/>
                     <a:p>
-                      <a:pPr algn="r" indent="0" marL="0">
+                      <a:pPr marL="0" indent="0" algn="r">
                         <a:buNone/>
                       </a:pPr>
                       <a:r>
@@ -16185,7 +15987,7 @@
                     <a:bodyPr/>
                     <a:lstStyle/>
                     <a:p>
-                      <a:pPr algn="r" indent="0" marL="0">
+                      <a:pPr marL="0" indent="0" algn="r">
                         <a:buNone/>
                       </a:pPr>
                       <a:r>
@@ -16274,7 +16076,7 @@
           <a:bodyPr wrap="square" lIns="0" tIns="0" rIns="0" bIns="0" rtlCol="0" anchor="t"/>
           <a:lstStyle/>
           <a:p>
-            <a:pPr indent="0" marL="0">
+            <a:pPr marL="0" indent="0">
               <a:buNone/>
             </a:pPr>
             <a:r>
@@ -16312,7 +16114,7 @@
           </a:prstGeom>
           <a:extLst>
             <a:ext uri="{C572A759-6A51-4108-AA02-DFA0A04FC94B}">
-              <ma14:wrappingTextBoxFlag xmlns:ma14="http://schemas.microsoft.com/office/mac/drawingml/2011/main" val="0"/>
+              <ma14:wrappingTextBoxFlag xmlns:ma14="http://schemas.microsoft.com/office/mac/drawingml/2011/main" xmlns="" val="0"/>
             </a:ext>
           </a:extLst>
         </p:spPr>
@@ -16333,7 +16135,7 @@
           <a:p>
             <a:pPr algn="l"/>
             <a:fld id="{F7021451-1387-4CA6-816F-3879F97B5CBC}" type="slidenum">
-              <a:rPr b="0" lang="en-US"/>
+              <a:rPr lang="en-US" b="0"/>
               <a:t>7</a:t>
             </a:fld>
             <a:endParaRPr lang="en-US"/>
@@ -16368,9 +16170,11 @@
       <p:sp>
         <p:nvSpPr>
           <p:cNvPr id="2" name="Text 0"/>
-          <p:cNvSpPr/>
+          <p:cNvSpPr>
+            <a:spLocks noGrp="1"/>
+          </p:cNvSpPr>
           <p:nvPr>
-            <p:ph idx="100" type="body" hasCustomPrompt="1"/>
+            <p:ph type="body" idx="100" hasCustomPrompt="1"/>
           </p:nvPr>
         </p:nvSpPr>
         <p:spPr>
@@ -16388,11 +16192,11 @@
           <a:bodyPr wrap="square" lIns="0" tIns="0" rIns="0" bIns="0" rtlCol="0"/>
           <a:lstStyle/>
           <a:p>
-            <a:pPr indent="0" marL="0">
+            <a:pPr marL="0" indent="0">
               <a:buNone/>
             </a:pPr>
             <a:r>
-              <a:rPr lang="en-US" sz="1300" spc="200" kern="0" dirty="0">
+              <a:rPr lang="en-US" sz="1300" kern="0" spc="200" dirty="0">
                 <a:solidFill>
                   <a:srgbClr val="B5561C"/>
                 </a:solidFill>
@@ -16409,9 +16213,11 @@
       <p:sp>
         <p:nvSpPr>
           <p:cNvPr id="3" name="Text 0"/>
-          <p:cNvSpPr/>
+          <p:cNvSpPr>
+            <a:spLocks noGrp="1"/>
+          </p:cNvSpPr>
           <p:nvPr>
-            <p:ph idx="101" type="title" hasCustomPrompt="1"/>
+            <p:ph type="title" idx="101" hasCustomPrompt="1"/>
           </p:nvPr>
         </p:nvSpPr>
         <p:spPr>
@@ -16429,7 +16235,7 @@
           <a:bodyPr wrap="square" lIns="0" tIns="0" rIns="0" bIns="0" rtlCol="0" anchor="t"/>
           <a:lstStyle/>
           <a:p>
-            <a:pPr algn="l" indent="0" marL="0">
+            <a:pPr marL="0" indent="0" algn="l">
               <a:buNone/>
             </a:pPr>
             <a:r>
@@ -16449,7 +16255,7 @@
       </p:sp>
       <p:graphicFrame>
         <p:nvGraphicFramePr>
-          <p:cNvPr id="4" name="Chart 0" descr=""/>
+          <p:cNvPr id="4" name="Chart 0"/>
           <p:cNvGraphicFramePr/>
           <p:nvPr/>
         </p:nvGraphicFramePr>
@@ -16457,15 +16263,15 @@
           <a:off x="548640" y="1737360"/>
           <a:ext cx="6035040" cy="4206240"/>
         </p:xfrm>
-        <a:graphic xmlns:a="http://schemas.openxmlformats.org/drawingml/2006/main">
+        <a:graphic>
           <a:graphicData uri="http://schemas.openxmlformats.org/drawingml/2006/chart">
-            <c:chart xmlns:c="http://schemas.openxmlformats.org/drawingml/2006/chart" r:id="rId1"/>
+            <c:chart xmlns:c="http://schemas.openxmlformats.org/drawingml/2006/chart" xmlns:r="http://schemas.openxmlformats.org/officeDocument/2006/relationships" r:id="rId3"/>
           </a:graphicData>
         </a:graphic>
       </p:graphicFrame>
       <p:graphicFrame>
         <p:nvGraphicFramePr>
-          <p:cNvPr id="5" name="Chart 1" descr=""/>
+          <p:cNvPr id="5" name="Chart 1"/>
           <p:cNvGraphicFramePr/>
           <p:nvPr/>
         </p:nvGraphicFramePr>
@@ -16473,9 +16279,9 @@
           <a:off x="6766560" y="1737360"/>
           <a:ext cx="4846320" cy="4206240"/>
         </p:xfrm>
-        <a:graphic xmlns:a="http://schemas.openxmlformats.org/drawingml/2006/main">
+        <a:graphic>
           <a:graphicData uri="http://schemas.openxmlformats.org/drawingml/2006/chart">
-            <c:chart xmlns:c="http://schemas.openxmlformats.org/drawingml/2006/chart" r:id="rId2"/>
+            <c:chart xmlns:c="http://schemas.openxmlformats.org/drawingml/2006/chart" xmlns:r="http://schemas.openxmlformats.org/officeDocument/2006/relationships" r:id="rId4"/>
           </a:graphicData>
         </a:graphic>
       </p:graphicFrame>
@@ -16500,7 +16306,7 @@
           <a:bodyPr wrap="square" lIns="0" tIns="0" rIns="0" bIns="0" rtlCol="0" anchor="t"/>
           <a:lstStyle/>
           <a:p>
-            <a:pPr indent="0" marL="0">
+            <a:pPr marL="0" indent="0">
               <a:buNone/>
             </a:pPr>
             <a:r>
@@ -16538,7 +16344,7 @@
           </a:prstGeom>
           <a:extLst>
             <a:ext uri="{C572A759-6A51-4108-AA02-DFA0A04FC94B}">
-              <ma14:wrappingTextBoxFlag xmlns:ma14="http://schemas.microsoft.com/office/mac/drawingml/2011/main" val="0"/>
+              <ma14:wrappingTextBoxFlag xmlns:ma14="http://schemas.microsoft.com/office/mac/drawingml/2011/main" xmlns="" val="0"/>
             </a:ext>
           </a:extLst>
         </p:spPr>
@@ -16559,7 +16365,7 @@
           <a:p>
             <a:pPr algn="l"/>
             <a:fld id="{F7021451-1387-4CA6-816F-3879F97B5CBC}" type="slidenum">
-              <a:rPr b="0" lang="en-US"/>
+              <a:rPr lang="en-US" b="0"/>
               <a:t>8</a:t>
             </a:fld>
             <a:endParaRPr lang="en-US"/>
@@ -16612,11 +16418,11 @@
           <a:bodyPr wrap="square" lIns="0" tIns="0" rIns="0" bIns="0" rtlCol="0" anchor="t"/>
           <a:lstStyle/>
           <a:p>
-            <a:pPr indent="0" marL="0">
+            <a:pPr marL="0" indent="0">
               <a:buNone/>
             </a:pPr>
             <a:r>
-              <a:rPr lang="en-US" sz="1400" spc="200" kern="0" dirty="0">
+              <a:rPr lang="en-US" sz="1400" kern="0" spc="200" dirty="0">
                 <a:solidFill>
                   <a:srgbClr val="F2A65A"/>
                 </a:solidFill>
@@ -16651,7 +16457,7 @@
           <a:bodyPr wrap="square" lIns="0" tIns="0" rIns="0" bIns="0" rtlCol="0" anchor="t"/>
           <a:lstStyle/>
           <a:p>
-            <a:pPr indent="0" marL="0">
+            <a:pPr marL="0" indent="0">
               <a:buNone/>
             </a:pPr>
             <a:r>
@@ -16690,7 +16496,7 @@
           <a:bodyPr wrap="square" lIns="0" tIns="0" rIns="0" bIns="0" rtlCol="0" anchor="t"/>
           <a:lstStyle/>
           <a:p>
-            <a:pPr indent="0" marL="0">
+            <a:pPr marL="0" indent="0">
               <a:buNone/>
             </a:pPr>
             <a:r>
@@ -16754,7 +16560,7 @@
           <a:bodyPr wrap="square" lIns="0" tIns="0" rIns="0" bIns="0" rtlCol="0" anchor="t"/>
           <a:lstStyle/>
           <a:p>
-            <a:pPr indent="0" marL="0">
+            <a:pPr marL="0" indent="0">
               <a:buNone/>
             </a:pPr>
             <a:r>
@@ -16793,7 +16599,7 @@
           <a:bodyPr wrap="square" lIns="0" tIns="0" rIns="0" bIns="0" rtlCol="0" anchor="t"/>
           <a:lstStyle/>
           <a:p>
-            <a:pPr indent="0" marL="0">
+            <a:pPr marL="0" indent="0">
               <a:buNone/>
             </a:pPr>
             <a:r>
@@ -16857,7 +16663,7 @@
           <a:bodyPr wrap="square" lIns="0" tIns="0" rIns="0" bIns="0" rtlCol="0" anchor="t"/>
           <a:lstStyle/>
           <a:p>
-            <a:pPr indent="0" marL="0">
+            <a:pPr marL="0" indent="0">
               <a:buNone/>
             </a:pPr>
             <a:r>
@@ -16896,7 +16702,7 @@
           <a:bodyPr wrap="square" lIns="0" tIns="0" rIns="0" bIns="0" rtlCol="0" anchor="t"/>
           <a:lstStyle/>
           <a:p>
-            <a:pPr indent="0" marL="0">
+            <a:pPr marL="0" indent="0">
               <a:buNone/>
             </a:pPr>
             <a:r>
@@ -16935,7 +16741,7 @@
           <a:bodyPr wrap="square" lIns="0" tIns="0" rIns="0" bIns="0" rtlCol="0" anchor="t"/>
           <a:lstStyle/>
           <a:p>
-            <a:pPr indent="0" marL="0">
+            <a:pPr marL="0" indent="0">
               <a:buNone/>
             </a:pPr>
             <a:r>
@@ -17254,4 +17060,265 @@
     </a:ext>
   </a:extLst>
 </a:theme>
+</file>
+
+<file path=ppt/theme/theme2.xml><?xml version="1.0" encoding="utf-8"?>
+<a:theme xmlns:a="http://schemas.openxmlformats.org/drawingml/2006/main" name="Office Theme">
+  <a:themeElements>
+    <a:clrScheme name="Office">
+      <a:dk1>
+        <a:sysClr val="windowText" lastClr="000000"/>
+      </a:dk1>
+      <a:lt1>
+        <a:sysClr val="window" lastClr="FFFFFF"/>
+      </a:lt1>
+      <a:dk2>
+        <a:srgbClr val="44546A"/>
+      </a:dk2>
+      <a:lt2>
+        <a:srgbClr val="E7E6E6"/>
+      </a:lt2>
+      <a:accent1>
+        <a:srgbClr val="5B9BD5"/>
+      </a:accent1>
+      <a:accent2>
+        <a:srgbClr val="ED7D31"/>
+      </a:accent2>
+      <a:accent3>
+        <a:srgbClr val="A5A5A5"/>
+      </a:accent3>
+      <a:accent4>
+        <a:srgbClr val="FFC000"/>
+      </a:accent4>
+      <a:accent5>
+        <a:srgbClr val="4472C4"/>
+      </a:accent5>
+      <a:accent6>
+        <a:srgbClr val="70AD47"/>
+      </a:accent6>
+      <a:hlink>
+        <a:srgbClr val="0563C1"/>
+      </a:hlink>
+      <a:folHlink>
+        <a:srgbClr val="954F72"/>
+      </a:folHlink>
+    </a:clrScheme>
+    <a:fontScheme name="Office">
+      <a:majorFont>
+        <a:latin typeface="Calibri Light" panose="020F0302020204030204"/>
+        <a:ea typeface=""/>
+        <a:cs typeface=""/>
+        <a:font script="Jpan" typeface="ＭＳ Ｐゴシック"/>
+        <a:font script="Hang" typeface="맑은 고딕"/>
+        <a:font script="Hans" typeface="宋体"/>
+        <a:font script="Hant" typeface="新細明體"/>
+        <a:font script="Arab" typeface="Times New Roman"/>
+        <a:font script="Hebr" typeface="Times New Roman"/>
+        <a:font script="Thai" typeface="Angsana New"/>
+        <a:font script="Ethi" typeface="Nyala"/>
+        <a:font script="Beng" typeface="Vrinda"/>
+        <a:font script="Gujr" typeface="Shruti"/>
+        <a:font script="Khmr" typeface="MoolBoran"/>
+        <a:font script="Knda" typeface="Tunga"/>
+        <a:font script="Guru" typeface="Raavi"/>
+        <a:font script="Cans" typeface="Euphemia"/>
+        <a:font script="Cher" typeface="Plantagenet Cherokee"/>
+        <a:font script="Yiii" typeface="Microsoft Yi Baiti"/>
+        <a:font script="Tibt" typeface="Microsoft Himalaya"/>
+        <a:font script="Thaa" typeface="MV Boli"/>
+        <a:font script="Deva" typeface="Mangal"/>
+        <a:font script="Telu" typeface="Gautami"/>
+        <a:font script="Taml" typeface="Latha"/>
+        <a:font script="Syrc" typeface="Estrangelo Edessa"/>
+        <a:font script="Orya" typeface="Kalinga"/>
+        <a:font script="Mlym" typeface="Kartika"/>
+        <a:font script="Laoo" typeface="DokChampa"/>
+        <a:font script="Sinh" typeface="Iskoola Pota"/>
+        <a:font script="Mong" typeface="Mongolian Baiti"/>
+        <a:font script="Viet" typeface="Times New Roman"/>
+        <a:font script="Uigh" typeface="Microsoft Uighur"/>
+        <a:font script="Geor" typeface="Sylfaen"/>
+      </a:majorFont>
+      <a:minorFont>
+        <a:latin typeface="Calibri" panose="020F0502020204030204"/>
+        <a:ea typeface=""/>
+        <a:cs typeface=""/>
+        <a:font script="Jpan" typeface="ＭＳ Ｐゴシック"/>
+        <a:font script="Hang" typeface="맑은 고딕"/>
+        <a:font script="Hans" typeface="宋体"/>
+        <a:font script="Hant" typeface="新細明體"/>
+        <a:font script="Arab" typeface="Arial"/>
+        <a:font script="Hebr" typeface="Arial"/>
+        <a:font script="Thai" typeface="Cordia New"/>
+        <a:font script="Ethi" typeface="Nyala"/>
+        <a:font script="Beng" typeface="Vrinda"/>
+        <a:font script="Gujr" typeface="Shruti"/>
+        <a:font script="Khmr" typeface="DaunPenh"/>
+        <a:font script="Knda" typeface="Tunga"/>
+        <a:font script="Guru" typeface="Raavi"/>
+        <a:font script="Cans" typeface="Euphemia"/>
+        <a:font script="Cher" typeface="Plantagenet Cherokee"/>
+        <a:font script="Yiii" typeface="Microsoft Yi Baiti"/>
+        <a:font script="Tibt" typeface="Microsoft Himalaya"/>
+        <a:font script="Thaa" typeface="MV Boli"/>
+        <a:font script="Deva" typeface="Mangal"/>
+        <a:font script="Telu" typeface="Gautami"/>
+        <a:font script="Taml" typeface="Latha"/>
+        <a:font script="Syrc" typeface="Estrangelo Edessa"/>
+        <a:font script="Orya" typeface="Kalinga"/>
+        <a:font script="Mlym" typeface="Kartika"/>
+        <a:font script="Laoo" typeface="DokChampa"/>
+        <a:font script="Sinh" typeface="Iskoola Pota"/>
+        <a:font script="Mong" typeface="Mongolian Baiti"/>
+        <a:font script="Viet" typeface="Arial"/>
+        <a:font script="Uigh" typeface="Microsoft Uighur"/>
+        <a:font script="Geor" typeface="Sylfaen"/>
+      </a:minorFont>
+    </a:fontScheme>
+    <a:fmtScheme name="Office">
+      <a:fillStyleLst>
+        <a:solidFill>
+          <a:schemeClr val="phClr"/>
+        </a:solidFill>
+        <a:gradFill rotWithShape="1">
+          <a:gsLst>
+            <a:gs pos="0">
+              <a:schemeClr val="phClr">
+                <a:lumMod val="110000"/>
+                <a:satMod val="105000"/>
+                <a:tint val="67000"/>
+              </a:schemeClr>
+            </a:gs>
+            <a:gs pos="50000">
+              <a:schemeClr val="phClr">
+                <a:lumMod val="105000"/>
+                <a:satMod val="103000"/>
+                <a:tint val="73000"/>
+              </a:schemeClr>
+            </a:gs>
+            <a:gs pos="100000">
+              <a:schemeClr val="phClr">
+                <a:lumMod val="105000"/>
+                <a:satMod val="109000"/>
+                <a:tint val="81000"/>
+              </a:schemeClr>
+            </a:gs>
+          </a:gsLst>
+          <a:lin ang="5400000" scaled="0"/>
+        </a:gradFill>
+        <a:gradFill rotWithShape="1">
+          <a:gsLst>
+            <a:gs pos="0">
+              <a:schemeClr val="phClr">
+                <a:satMod val="103000"/>
+                <a:lumMod val="102000"/>
+                <a:tint val="94000"/>
+              </a:schemeClr>
+            </a:gs>
+            <a:gs pos="50000">
+              <a:schemeClr val="phClr">
+                <a:satMod val="110000"/>
+                <a:lumMod val="100000"/>
+                <a:shade val="100000"/>
+              </a:schemeClr>
+            </a:gs>
+            <a:gs pos="100000">
+              <a:schemeClr val="phClr">
+                <a:lumMod val="99000"/>
+                <a:satMod val="120000"/>
+                <a:shade val="78000"/>
+              </a:schemeClr>
+            </a:gs>
+          </a:gsLst>
+          <a:lin ang="5400000" scaled="0"/>
+        </a:gradFill>
+      </a:fillStyleLst>
+      <a:lnStyleLst>
+        <a:ln w="6350" cap="flat" cmpd="sng" algn="ctr">
+          <a:solidFill>
+            <a:schemeClr val="phClr"/>
+          </a:solidFill>
+          <a:prstDash val="solid"/>
+          <a:miter lim="800000"/>
+        </a:ln>
+        <a:ln w="12700" cap="flat" cmpd="sng" algn="ctr">
+          <a:solidFill>
+            <a:schemeClr val="phClr"/>
+          </a:solidFill>
+          <a:prstDash val="solid"/>
+          <a:miter lim="800000"/>
+        </a:ln>
+        <a:ln w="19050" cap="flat" cmpd="sng" algn="ctr">
+          <a:solidFill>
+            <a:schemeClr val="phClr"/>
+          </a:solidFill>
+          <a:prstDash val="solid"/>
+          <a:miter lim="800000"/>
+        </a:ln>
+      </a:lnStyleLst>
+      <a:effectStyleLst>
+        <a:effectStyle>
+          <a:effectLst/>
+        </a:effectStyle>
+        <a:effectStyle>
+          <a:effectLst/>
+        </a:effectStyle>
+        <a:effectStyle>
+          <a:effectLst>
+            <a:outerShdw blurRad="57150" dist="19050" dir="5400000" algn="ctr" rotWithShape="0">
+              <a:srgbClr val="000000">
+                <a:alpha val="63000"/>
+              </a:srgbClr>
+            </a:outerShdw>
+          </a:effectLst>
+        </a:effectStyle>
+      </a:effectStyleLst>
+      <a:bgFillStyleLst>
+        <a:solidFill>
+          <a:schemeClr val="phClr"/>
+        </a:solidFill>
+        <a:solidFill>
+          <a:schemeClr val="phClr">
+            <a:tint val="95000"/>
+            <a:satMod val="170000"/>
+          </a:schemeClr>
+        </a:solidFill>
+        <a:gradFill rotWithShape="1">
+          <a:gsLst>
+            <a:gs pos="0">
+              <a:schemeClr val="phClr">
+                <a:tint val="93000"/>
+                <a:satMod val="150000"/>
+                <a:shade val="98000"/>
+                <a:lumMod val="102000"/>
+              </a:schemeClr>
+            </a:gs>
+            <a:gs pos="50000">
+              <a:schemeClr val="phClr">
+                <a:tint val="98000"/>
+                <a:satMod val="130000"/>
+                <a:shade val="90000"/>
+                <a:lumMod val="103000"/>
+              </a:schemeClr>
+            </a:gs>
+            <a:gs pos="100000">
+              <a:schemeClr val="phClr">
+                <a:shade val="63000"/>
+                <a:satMod val="120000"/>
+              </a:schemeClr>
+            </a:gs>
+          </a:gsLst>
+          <a:lin ang="5400000" scaled="0"/>
+        </a:gradFill>
+      </a:bgFillStyleLst>
+    </a:fmtScheme>
+  </a:themeElements>
+  <a:objectDefaults/>
+  <a:extraClrSchemeLst/>
+  <a:extLst>
+    <a:ext uri="{05A4C25C-085E-4340-85A3-A5531E510DB2}">
+      <thm15:themeFamily xmlns:thm15="http://schemas.microsoft.com/office/thememl/2012/main" name="Office Theme" id="{62F939B6-93AF-4DB8-9C6B-D6C7DFDC589F}" vid="{4A3C46E8-61CC-4603-A589-7422A47A8E4A}"/>
+    </a:ext>
+  </a:extLst>
+</a:theme>
 </file>
</xml_diff>